<commit_message>
Add layout analysis, human-in-the-loop, and sampling-at-scale to Module 2 deck
Reframes the old "beyond just tokens" slide as its own Layout Analysis
topic, adds a Human-in-the-Loop slide making the flag-review workflow
explicit, and adds a Sampling At Scale slide covering how to validate
once the corpus is hundreds of documents instead of 3 -- targeted 100%
review of anything flagged, plus a random audit sample of the rest to
catch false negatives. Framed explicitly as methodology, not a result,
since the real corpus here is still 3 documents.

Co-Authored-By: Claude Sonnet 5 <noreply@anthropic.com>
</commit_message>
<xml_diff>
--- a/2. ANALYSIS/Analysis_Module_Overview.pptx
+++ b/2. ANALYSIS/Analysis_Module_Overview.pptx
@@ -19,6 +19,8 @@
     <p:sldId id="267" r:id="rId18"/>
     <p:sldId id="268" r:id="rId19"/>
     <p:sldId id="269" r:id="rId20"/>
+    <p:sldId id="270" r:id="rId21"/>
+    <p:sldId id="271" r:id="rId22"/>
   </p:sldIdLst>
   <p:sldSz cx="12191695" cy="6858000" type="screen4x3"/>
   <p:notesSz cx="6858000" cy="9144000"/>
@@ -3652,7 +3654,7 @@
                 </a:solidFill>
                 <a:latin typeface="Calibri"/>
               </a:rPr>
-              <a:t>A VALIDATION HABIT</a:t>
+              <a:t>HUMAN-IN-THE-LOOP, BY DESIGN</a:t>
             </a:r>
           </a:p>
         </p:txBody>
@@ -3687,7 +3689,7 @@
                 </a:solidFill>
                 <a:latin typeface="Calibri"/>
               </a:rPr>
-              <a:t>Tokens/Page as an Anomaly Signal</a:t>
+              <a:t>A Flag Is Only Useful If Someone Can Act On It</a:t>
             </a:r>
           </a:p>
         </p:txBody>
@@ -3716,81 +3718,81 @@
           <a:p>
             <a:pPr>
               <a:spcAft>
-                <a:spcPts val="1200"/>
+                <a:spcPts val="1000"/>
               </a:spcAft>
             </a:pPr>
             <a:r>
-              <a:rPr sz="2000" b="1">
+              <a:rPr sz="1800" b="1">
                 <a:solidFill>
                   <a:srgbClr val="1A1D27"/>
                 </a:solidFill>
                 <a:latin typeface="Calibri"/>
               </a:rPr>
-              <a:t>▸  There's no universal “correct” tokens-per-page number -- it depends entirely on the document type</a:t>
+              <a:t>▸  Every flagged row -- low confidence, dropped region, malformed table -- carries a page number and a bounding box back to the original document</a:t>
             </a:r>
           </a:p>
           <a:p>
             <a:pPr>
               <a:spcAft>
-                <a:spcPts val="1200"/>
+                <a:spcPts val="1000"/>
               </a:spcAft>
             </a:pPr>
             <a:r>
-              <a:rPr sz="2000" b="1">
+              <a:rPr sz="1800" b="1">
                 <a:solidFill>
                   <a:srgbClr val="1A1D27"/>
                 </a:solidFill>
                 <a:latin typeface="Calibri"/>
               </a:rPr>
-              <a:t>▸  But once you have it for a batch of similar documents, an outlier is worth a look:</a:t>
+              <a:t>▸  That's not incidental: it's what turns a flag into a 30-second check instead of a full re-read of the document</a:t>
             </a:r>
           </a:p>
           <a:p>
             <a:pPr>
               <a:spcAft>
-                <a:spcPts val="600"/>
+                <a:spcPts val="1000"/>
               </a:spcAft>
             </a:pPr>
             <a:r>
-              <a:rPr sz="1600" b="0">
-                <a:solidFill>
-                  <a:srgbClr val="5B6374"/>
-                </a:solidFill>
-                <a:latin typeface="Calibri"/>
-              </a:rPr>
-              <a:t>     –  Much LOWER than its peers -- possible sign of missed or truncated content</a:t>
+              <a:rPr sz="1800" b="1">
+                <a:solidFill>
+                  <a:srgbClr val="1A1D27"/>
+                </a:solidFill>
+                <a:latin typeface="Calibri"/>
+              </a:rPr>
+              <a:t>▸  The loop: detector flags an uncertain region → it lands in the Excel workbook → a person looks at that exact spot on the original page → confirms a real problem, or clears it as a false alarm</a:t>
             </a:r>
           </a:p>
           <a:p>
             <a:pPr>
               <a:spcAft>
-                <a:spcPts val="600"/>
+                <a:spcPts val="500"/>
               </a:spcAft>
             </a:pPr>
             <a:r>
-              <a:rPr sz="1600" b="0">
+              <a:rPr sz="1500" b="0">
                 <a:solidFill>
                   <a:srgbClr val="5B6374"/>
                 </a:solidFill>
                 <a:latin typeface="Calibri"/>
               </a:rPr>
-              <a:t>     –  Much HIGHER than its peers -- possible sign of garbled or repeated extraction output</a:t>
+              <a:t>     –  The logo case study on the previous slide is this loop working end to end -- a two-minute human check catching a bug automation alone missed</a:t>
             </a:r>
           </a:p>
           <a:p>
             <a:pPr>
               <a:spcAft>
-                <a:spcPts val="1200"/>
+                <a:spcPts val="1000"/>
               </a:spcAft>
             </a:pPr>
             <a:r>
-              <a:rPr sz="2000" b="1">
+              <a:rPr sz="1800" b="1">
                 <a:solidFill>
                   <a:srgbClr val="1A1D27"/>
                 </a:solidFill>
                 <a:latin typeface="Calibri"/>
               </a:rPr>
-              <a:t>▸  The value isn't any single number -- it's being able to scan 50 rows and immediately see which ones don't look like the rest</a:t>
+              <a:t>▸  What this module doesn't do yet: feed a human's correction back into re-thresholding or retraining the detector -- that's the natural next step, not built here</a:t>
             </a:r>
           </a:p>
         </p:txBody>
@@ -3929,7 +3931,7 @@
                 </a:solidFill>
                 <a:latin typeface="Calibri"/>
               </a:rPr>
-              <a:t>A QUIET DETAIL</a:t>
+              <a:t>A VALIDATION HABIT</a:t>
             </a:r>
           </a:p>
         </p:txBody>
@@ -3964,7 +3966,7 @@
                 </a:solidFill>
                 <a:latin typeface="Calibri"/>
               </a:rPr>
-              <a:t>Partial Runs Get Skipped, Not Guessed At</a:t>
+              <a:t>Tokens/Page as an Anomaly Signal</a:t>
             </a:r>
           </a:p>
         </p:txBody>
@@ -4003,7 +4005,7 @@
                 </a:solidFill>
                 <a:latin typeface="Calibri"/>
               </a:rPr>
-              <a:t>▸  A document only gets analyzed once its extraction has actually finished, not while it's still in progress</a:t>
+              <a:t>▸  There's no universal “correct” tokens-per-page number -- it depends entirely on the document type</a:t>
             </a:r>
           </a:p>
           <a:p>
@@ -4019,7 +4021,39 @@
                 </a:solidFill>
                 <a:latin typeface="Calibri"/>
               </a:rPr>
-              <a:t>▸  An interrupted or still-running extraction leaves incomplete output</a:t>
+              <a:t>▸  But once you have it for a batch of similar documents, an outlier is worth a look:</a:t>
+            </a:r>
+          </a:p>
+          <a:p>
+            <a:pPr>
+              <a:spcAft>
+                <a:spcPts val="600"/>
+              </a:spcAft>
+            </a:pPr>
+            <a:r>
+              <a:rPr sz="1600" b="0">
+                <a:solidFill>
+                  <a:srgbClr val="5B6374"/>
+                </a:solidFill>
+                <a:latin typeface="Calibri"/>
+              </a:rPr>
+              <a:t>     –  Much LOWER than its peers -- possible sign of missed or truncated content</a:t>
+            </a:r>
+          </a:p>
+          <a:p>
+            <a:pPr>
+              <a:spcAft>
+                <a:spcPts val="600"/>
+              </a:spcAft>
+            </a:pPr>
+            <a:r>
+              <a:rPr sz="1600" b="0">
+                <a:solidFill>
+                  <a:srgbClr val="5B6374"/>
+                </a:solidFill>
+                <a:latin typeface="Calibri"/>
+              </a:rPr>
+              <a:t>     –  Much HIGHER than its peers -- possible sign of garbled or repeated extraction output</a:t>
             </a:r>
           </a:p>
           <a:p>
@@ -4035,7 +4069,7 @@
                 </a:solidFill>
                 <a:latin typeface="Calibri"/>
               </a:rPr>
-              <a:t>▸  That incomplete output gets skipped rather than guessed at -- a document either finished cleanly, or it isn't validated at all</a:t>
+              <a:t>▸  The value isn't any single number -- it's being able to scan 50 rows and immediately see which ones don't look like the rest</a:t>
             </a:r>
           </a:p>
         </p:txBody>
@@ -4174,7 +4208,7 @@
                 </a:solidFill>
                 <a:latin typeface="Calibri"/>
               </a:rPr>
-              <a:t>WRAP-UP</a:t>
+              <a:t>SAMPLING AT SCALE</a:t>
             </a:r>
           </a:p>
         </p:txBody>
@@ -4209,7 +4243,7 @@
                 </a:solidFill>
                 <a:latin typeface="Calibri"/>
               </a:rPr>
-              <a:t>Why This Module Matters</a:t>
+              <a:t>From 3 Documents to 3,000</a:t>
             </a:r>
           </a:p>
         </p:txBody>
@@ -4238,65 +4272,97 @@
           <a:p>
             <a:pPr>
               <a:spcAft>
-                <a:spcPts val="1200"/>
+                <a:spcPts val="800"/>
               </a:spcAft>
             </a:pPr>
             <a:r>
-              <a:rPr sz="2000" b="1">
+              <a:rPr sz="1600" b="1">
                 <a:solidFill>
                   <a:srgbClr val="1A1D27"/>
                 </a:solidFill>
                 <a:latin typeface="Calibri"/>
               </a:rPr>
-              <a:t>▸  It turns “the pipeline didn't crash” into “here's proof this document is actually usable”</a:t>
+              <a:t>▸  This module's corpus is 3 real documents -- reviewing every flagged row by hand is trivial at that size. It stops being trivial well before you reach a few thousand</a:t>
             </a:r>
           </a:p>
           <a:p>
             <a:pPr>
               <a:spcAft>
-                <a:spcPts val="1200"/>
+                <a:spcPts val="800"/>
               </a:spcAft>
             </a:pPr>
             <a:r>
-              <a:rPr sz="2000" b="1">
+              <a:rPr sz="1600" b="1">
                 <a:solidFill>
                   <a:srgbClr val="1A1D27"/>
                 </a:solidFill>
                 <a:latin typeface="Calibri"/>
               </a:rPr>
-              <a:t>▸  It lets one person identify which of many documents need a closer look, without opening every single one</a:t>
+              <a:t>▸  The fix isn't reviewing everything, and it isn't reviewing a random handful either -- it's spending human attention where the model already told you it's unsure</a:t>
             </a:r>
           </a:p>
           <a:p>
             <a:pPr>
               <a:spcAft>
-                <a:spcPts val="1200"/>
+                <a:spcPts val="400"/>
               </a:spcAft>
             </a:pPr>
             <a:r>
-              <a:rPr sz="2000" b="1">
-                <a:solidFill>
-                  <a:srgbClr val="1A1D27"/>
-                </a:solidFill>
-                <a:latin typeface="Calibri"/>
-              </a:rPr>
-              <a:t>▸  It turns a hidden extraction bug into a traceable, fixable finding, instead of a silent quality problem downstream</a:t>
+              <a:rPr sz="1300" b="0">
+                <a:solidFill>
+                  <a:srgbClr val="5B6374"/>
+                </a:solidFill>
+                <a:latin typeface="Calibri"/>
+              </a:rPr>
+              <a:t>     –  Targeted review, 100% coverage -- every document with any low-confidence region, dropped region, or malformed table. Usually a small minority of the corpus, which is exactly why full coverage stays affordable</a:t>
             </a:r>
           </a:p>
           <a:p>
             <a:pPr>
               <a:spcAft>
-                <a:spcPts val="1200"/>
+                <a:spcPts val="400"/>
               </a:spcAft>
             </a:pPr>
             <a:r>
-              <a:rPr sz="2000" b="1">
+              <a:rPr sz="1300" b="0">
+                <a:solidFill>
+                  <a:srgbClr val="5B6374"/>
+                </a:solidFill>
+                <a:latin typeface="Calibri"/>
+              </a:rPr>
+              <a:t>     –  Random audit sample of the rest -- a small percentage (5-10% is a common starting point) of documents that came back with zero flags, specifically to catch cases where the detector is confidently wrong</a:t>
+            </a:r>
+          </a:p>
+          <a:p>
+            <a:pPr>
+              <a:spcAft>
+                <a:spcPts val="800"/>
+              </a:spcAft>
+            </a:pPr>
+            <a:r>
+              <a:rPr sz="1600" b="1">
                 <a:solidFill>
                   <a:srgbClr val="1A1D27"/>
                 </a:solidFill>
                 <a:latin typeface="Calibri"/>
               </a:rPr>
-              <a:t>▸  Next: Module 3 takes this same validated output and turns it into retrieval-ready chunks -- recursive, semantic, and hierarchical strategies, compared on the same real documents</a:t>
+              <a:t>▸  Why the second bucket matters: a validation system that only ever double-checks its own doubts can't catch its own blind spots -- the audit sample is how you find out if “zero flags” is actually trustworthy</a:t>
+            </a:r>
+          </a:p>
+          <a:p>
+            <a:pPr>
+              <a:spcAft>
+                <a:spcPts val="800"/>
+              </a:spcAft>
+            </a:pPr>
+            <a:r>
+              <a:rPr sz="1600" b="1">
+                <a:solidFill>
+                  <a:srgbClr val="1A1D27"/>
+                </a:solidFill>
+                <a:latin typeface="Calibri"/>
+              </a:rPr>
+              <a:t>▸  Tokens/page outliers (previous slide) feed the same triage -- an outlier is one more reason to pull a document into the reviewed set even with zero layout flags</a:t>
             </a:r>
           </a:p>
         </p:txBody>
@@ -4304,6 +4370,41 @@
       <p:sp>
         <p:nvSpPr>
           <p:cNvPr id="6" name="TextBox 5"/>
+          <p:cNvSpPr txBox="1"/>
+          <p:nvPr/>
+        </p:nvSpPr>
+        <p:spPr>
+          <a:xfrm>
+            <a:off x="731520" y="6263640"/>
+            <a:ext cx="10698480" cy="411480"/>
+          </a:xfrm>
+          <a:prstGeom prst="rect">
+            <a:avLst/>
+          </a:prstGeom>
+          <a:noFill/>
+        </p:spPr>
+        <p:txBody>
+          <a:bodyPr wrap="square">
+            <a:spAutoFit/>
+          </a:bodyPr>
+          <a:lstStyle/>
+          <a:p>
+            <a:pPr algn="l"/>
+            <a:r>
+              <a:rPr sz="1200" b="0" i="1">
+                <a:solidFill>
+                  <a:srgbClr val="5B6374"/>
+                </a:solidFill>
+                <a:latin typeface="Calibri"/>
+              </a:rPr>
+              <a:t>This is methodology, not a result -- honest about what a 3-document teaching corpus can and can't demonstrate. The same low_confidence_count / dropped_region_count / tokens_per_page columns already in the Excel report are exactly what a sampling rule would key off of at real scale.</a:t>
+            </a:r>
+          </a:p>
+        </p:txBody>
+      </p:sp>
+      <p:sp>
+        <p:nvSpPr>
+          <p:cNvPr id="7" name="TextBox 6"/>
           <p:cNvSpPr txBox="1"/>
           <p:nvPr/>
         </p:nvSpPr>
@@ -4345,6 +4446,528 @@
 </file>
 
 <file path=ppt/slides/slide14.xml><?xml version="1.0" encoding="utf-8"?>
+<p:sld xmlns:a="http://schemas.openxmlformats.org/drawingml/2006/main" xmlns:p="http://schemas.openxmlformats.org/presentationml/2006/main" xmlns:r="http://schemas.openxmlformats.org/officeDocument/2006/relationships">
+  <p:cSld>
+    <p:bg>
+      <p:bgPr>
+        <a:solidFill>
+          <a:srgbClr val="FFFFFF"/>
+        </a:solidFill>
+        <a:effectLst/>
+      </p:bgPr>
+    </p:bg>
+    <p:spTree>
+      <p:nvGrpSpPr>
+        <p:cNvPr id="1" name=""/>
+        <p:cNvGrpSpPr/>
+        <p:nvPr/>
+      </p:nvGrpSpPr>
+      <p:grpSpPr/>
+      <p:sp>
+        <p:nvSpPr>
+          <p:cNvPr id="2" name="Rectangle 1"/>
+          <p:cNvSpPr/>
+          <p:nvPr/>
+        </p:nvSpPr>
+        <p:spPr>
+          <a:xfrm>
+            <a:off x="0" y="0"/>
+            <a:ext cx="12191695" cy="109728"/>
+          </a:xfrm>
+          <a:prstGeom prst="rect">
+            <a:avLst/>
+          </a:prstGeom>
+          <a:solidFill>
+            <a:srgbClr val="3E8EDE"/>
+          </a:solidFill>
+          <a:ln>
+            <a:noFill/>
+          </a:ln>
+        </p:spPr>
+        <p:style>
+          <a:lnRef idx="1">
+            <a:schemeClr val="accent1"/>
+          </a:lnRef>
+          <a:fillRef idx="3">
+            <a:schemeClr val="accent1"/>
+          </a:fillRef>
+          <a:effectRef idx="2">
+            <a:schemeClr val="accent1"/>
+          </a:effectRef>
+          <a:fontRef idx="minor">
+            <a:schemeClr val="lt1"/>
+          </a:fontRef>
+        </p:style>
+        <p:txBody>
+          <a:bodyPr rtlCol="0" anchor="ctr"/>
+          <a:lstStyle/>
+          <a:p>
+            <a:pPr algn="ctr"/>
+          </a:p>
+        </p:txBody>
+      </p:sp>
+      <p:sp>
+        <p:nvSpPr>
+          <p:cNvPr id="3" name="TextBox 2"/>
+          <p:cNvSpPr txBox="1"/>
+          <p:nvPr/>
+        </p:nvSpPr>
+        <p:spPr>
+          <a:xfrm>
+            <a:off x="640080" y="411480"/>
+            <a:ext cx="10881360" cy="457200"/>
+          </a:xfrm>
+          <a:prstGeom prst="rect">
+            <a:avLst/>
+          </a:prstGeom>
+          <a:noFill/>
+        </p:spPr>
+        <p:txBody>
+          <a:bodyPr wrap="square">
+            <a:spAutoFit/>
+          </a:bodyPr>
+          <a:lstStyle/>
+          <a:p>
+            <a:pPr algn="l"/>
+            <a:r>
+              <a:rPr sz="1500" b="1" i="0">
+                <a:solidFill>
+                  <a:srgbClr val="3E8EDE"/>
+                </a:solidFill>
+                <a:latin typeface="Calibri"/>
+              </a:rPr>
+              <a:t>A QUIET DETAIL</a:t>
+            </a:r>
+          </a:p>
+        </p:txBody>
+      </p:sp>
+      <p:sp>
+        <p:nvSpPr>
+          <p:cNvPr id="4" name="TextBox 3"/>
+          <p:cNvSpPr txBox="1"/>
+          <p:nvPr/>
+        </p:nvSpPr>
+        <p:spPr>
+          <a:xfrm>
+            <a:off x="640080" y="777240"/>
+            <a:ext cx="10881360" cy="822960"/>
+          </a:xfrm>
+          <a:prstGeom prst="rect">
+            <a:avLst/>
+          </a:prstGeom>
+          <a:noFill/>
+        </p:spPr>
+        <p:txBody>
+          <a:bodyPr wrap="square">
+            <a:spAutoFit/>
+          </a:bodyPr>
+          <a:lstStyle/>
+          <a:p>
+            <a:pPr algn="l"/>
+            <a:r>
+              <a:rPr sz="3000" b="1" i="0">
+                <a:solidFill>
+                  <a:srgbClr val="1A1D27"/>
+                </a:solidFill>
+                <a:latin typeface="Calibri"/>
+              </a:rPr>
+              <a:t>Partial Runs Get Skipped, Not Guessed At</a:t>
+            </a:r>
+          </a:p>
+        </p:txBody>
+      </p:sp>
+      <p:sp>
+        <p:nvSpPr>
+          <p:cNvPr id="5" name="TextBox 4"/>
+          <p:cNvSpPr txBox="1"/>
+          <p:nvPr/>
+        </p:nvSpPr>
+        <p:spPr>
+          <a:xfrm>
+            <a:off x="731520" y="1691640"/>
+            <a:ext cx="10698480" cy="4480560"/>
+          </a:xfrm>
+          <a:prstGeom prst="rect">
+            <a:avLst/>
+          </a:prstGeom>
+          <a:noFill/>
+        </p:spPr>
+        <p:txBody>
+          <a:bodyPr wrap="square">
+            <a:spAutoFit/>
+          </a:bodyPr>
+          <a:lstStyle/>
+          <a:p>
+            <a:pPr>
+              <a:spcAft>
+                <a:spcPts val="1200"/>
+              </a:spcAft>
+            </a:pPr>
+            <a:r>
+              <a:rPr sz="2000" b="1">
+                <a:solidFill>
+                  <a:srgbClr val="1A1D27"/>
+                </a:solidFill>
+                <a:latin typeface="Calibri"/>
+              </a:rPr>
+              <a:t>▸  A document only gets analyzed once its extraction has actually finished, not while it's still in progress</a:t>
+            </a:r>
+          </a:p>
+          <a:p>
+            <a:pPr>
+              <a:spcAft>
+                <a:spcPts val="1200"/>
+              </a:spcAft>
+            </a:pPr>
+            <a:r>
+              <a:rPr sz="2000" b="1">
+                <a:solidFill>
+                  <a:srgbClr val="1A1D27"/>
+                </a:solidFill>
+                <a:latin typeface="Calibri"/>
+              </a:rPr>
+              <a:t>▸  An interrupted or still-running extraction leaves incomplete output</a:t>
+            </a:r>
+          </a:p>
+          <a:p>
+            <a:pPr>
+              <a:spcAft>
+                <a:spcPts val="1200"/>
+              </a:spcAft>
+            </a:pPr>
+            <a:r>
+              <a:rPr sz="2000" b="1">
+                <a:solidFill>
+                  <a:srgbClr val="1A1D27"/>
+                </a:solidFill>
+                <a:latin typeface="Calibri"/>
+              </a:rPr>
+              <a:t>▸  That incomplete output gets skipped rather than guessed at -- a document either finished cleanly, or it isn't validated at all</a:t>
+            </a:r>
+          </a:p>
+        </p:txBody>
+      </p:sp>
+      <p:sp>
+        <p:nvSpPr>
+          <p:cNvPr id="6" name="TextBox 5"/>
+          <p:cNvSpPr txBox="1"/>
+          <p:nvPr/>
+        </p:nvSpPr>
+        <p:spPr>
+          <a:xfrm>
+            <a:off x="11521440" y="6446520"/>
+            <a:ext cx="548640" cy="320040"/>
+          </a:xfrm>
+          <a:prstGeom prst="rect">
+            <a:avLst/>
+          </a:prstGeom>
+          <a:noFill/>
+        </p:spPr>
+        <p:txBody>
+          <a:bodyPr wrap="square">
+            <a:spAutoFit/>
+          </a:bodyPr>
+          <a:lstStyle/>
+          <a:p>
+            <a:pPr algn="r"/>
+            <a:r>
+              <a:rPr sz="1100" b="0" i="0">
+                <a:solidFill>
+                  <a:srgbClr val="5B6374"/>
+                </a:solidFill>
+                <a:latin typeface="Calibri"/>
+              </a:rPr>
+              <a:t>14</a:t>
+            </a:r>
+          </a:p>
+        </p:txBody>
+      </p:sp>
+    </p:spTree>
+  </p:cSld>
+  <p:clrMapOvr>
+    <a:masterClrMapping/>
+  </p:clrMapOvr>
+</p:sld>
+</file>
+
+<file path=ppt/slides/slide15.xml><?xml version="1.0" encoding="utf-8"?>
+<p:sld xmlns:a="http://schemas.openxmlformats.org/drawingml/2006/main" xmlns:p="http://schemas.openxmlformats.org/presentationml/2006/main" xmlns:r="http://schemas.openxmlformats.org/officeDocument/2006/relationships">
+  <p:cSld>
+    <p:bg>
+      <p:bgPr>
+        <a:solidFill>
+          <a:srgbClr val="FFFFFF"/>
+        </a:solidFill>
+        <a:effectLst/>
+      </p:bgPr>
+    </p:bg>
+    <p:spTree>
+      <p:nvGrpSpPr>
+        <p:cNvPr id="1" name=""/>
+        <p:cNvGrpSpPr/>
+        <p:nvPr/>
+      </p:nvGrpSpPr>
+      <p:grpSpPr/>
+      <p:sp>
+        <p:nvSpPr>
+          <p:cNvPr id="2" name="Rectangle 1"/>
+          <p:cNvSpPr/>
+          <p:nvPr/>
+        </p:nvSpPr>
+        <p:spPr>
+          <a:xfrm>
+            <a:off x="0" y="0"/>
+            <a:ext cx="12191695" cy="109728"/>
+          </a:xfrm>
+          <a:prstGeom prst="rect">
+            <a:avLst/>
+          </a:prstGeom>
+          <a:solidFill>
+            <a:srgbClr val="3E8EDE"/>
+          </a:solidFill>
+          <a:ln>
+            <a:noFill/>
+          </a:ln>
+        </p:spPr>
+        <p:style>
+          <a:lnRef idx="1">
+            <a:schemeClr val="accent1"/>
+          </a:lnRef>
+          <a:fillRef idx="3">
+            <a:schemeClr val="accent1"/>
+          </a:fillRef>
+          <a:effectRef idx="2">
+            <a:schemeClr val="accent1"/>
+          </a:effectRef>
+          <a:fontRef idx="minor">
+            <a:schemeClr val="lt1"/>
+          </a:fontRef>
+        </p:style>
+        <p:txBody>
+          <a:bodyPr rtlCol="0" anchor="ctr"/>
+          <a:lstStyle/>
+          <a:p>
+            <a:pPr algn="ctr"/>
+          </a:p>
+        </p:txBody>
+      </p:sp>
+      <p:sp>
+        <p:nvSpPr>
+          <p:cNvPr id="3" name="TextBox 2"/>
+          <p:cNvSpPr txBox="1"/>
+          <p:nvPr/>
+        </p:nvSpPr>
+        <p:spPr>
+          <a:xfrm>
+            <a:off x="640080" y="411480"/>
+            <a:ext cx="10881360" cy="457200"/>
+          </a:xfrm>
+          <a:prstGeom prst="rect">
+            <a:avLst/>
+          </a:prstGeom>
+          <a:noFill/>
+        </p:spPr>
+        <p:txBody>
+          <a:bodyPr wrap="square">
+            <a:spAutoFit/>
+          </a:bodyPr>
+          <a:lstStyle/>
+          <a:p>
+            <a:pPr algn="l"/>
+            <a:r>
+              <a:rPr sz="1500" b="1" i="0">
+                <a:solidFill>
+                  <a:srgbClr val="3E8EDE"/>
+                </a:solidFill>
+                <a:latin typeface="Calibri"/>
+              </a:rPr>
+              <a:t>WRAP-UP</a:t>
+            </a:r>
+          </a:p>
+        </p:txBody>
+      </p:sp>
+      <p:sp>
+        <p:nvSpPr>
+          <p:cNvPr id="4" name="TextBox 3"/>
+          <p:cNvSpPr txBox="1"/>
+          <p:nvPr/>
+        </p:nvSpPr>
+        <p:spPr>
+          <a:xfrm>
+            <a:off x="640080" y="777240"/>
+            <a:ext cx="10881360" cy="822960"/>
+          </a:xfrm>
+          <a:prstGeom prst="rect">
+            <a:avLst/>
+          </a:prstGeom>
+          <a:noFill/>
+        </p:spPr>
+        <p:txBody>
+          <a:bodyPr wrap="square">
+            <a:spAutoFit/>
+          </a:bodyPr>
+          <a:lstStyle/>
+          <a:p>
+            <a:pPr algn="l"/>
+            <a:r>
+              <a:rPr sz="3000" b="1" i="0">
+                <a:solidFill>
+                  <a:srgbClr val="1A1D27"/>
+                </a:solidFill>
+                <a:latin typeface="Calibri"/>
+              </a:rPr>
+              <a:t>Why This Module Matters</a:t>
+            </a:r>
+          </a:p>
+        </p:txBody>
+      </p:sp>
+      <p:sp>
+        <p:nvSpPr>
+          <p:cNvPr id="5" name="TextBox 4"/>
+          <p:cNvSpPr txBox="1"/>
+          <p:nvPr/>
+        </p:nvSpPr>
+        <p:spPr>
+          <a:xfrm>
+            <a:off x="731520" y="1691640"/>
+            <a:ext cx="10698480" cy="4480560"/>
+          </a:xfrm>
+          <a:prstGeom prst="rect">
+            <a:avLst/>
+          </a:prstGeom>
+          <a:noFill/>
+        </p:spPr>
+        <p:txBody>
+          <a:bodyPr wrap="square">
+            <a:spAutoFit/>
+          </a:bodyPr>
+          <a:lstStyle/>
+          <a:p>
+            <a:pPr>
+              <a:spcAft>
+                <a:spcPts val="1000"/>
+              </a:spcAft>
+            </a:pPr>
+            <a:r>
+              <a:rPr sz="1800" b="1">
+                <a:solidFill>
+                  <a:srgbClr val="1A1D27"/>
+                </a:solidFill>
+                <a:latin typeface="Calibri"/>
+              </a:rPr>
+              <a:t>▸  It turns “the pipeline didn't crash” into “here's proof this document is actually usable”</a:t>
+            </a:r>
+          </a:p>
+          <a:p>
+            <a:pPr>
+              <a:spcAft>
+                <a:spcPts val="1000"/>
+              </a:spcAft>
+            </a:pPr>
+            <a:r>
+              <a:rPr sz="1800" b="1">
+                <a:solidFill>
+                  <a:srgbClr val="1A1D27"/>
+                </a:solidFill>
+                <a:latin typeface="Calibri"/>
+              </a:rPr>
+              <a:t>▸  Two independent checks, not one -- token analysis for how much came out, layout analysis for whether the model saw the page correctly</a:t>
+            </a:r>
+          </a:p>
+          <a:p>
+            <a:pPr>
+              <a:spcAft>
+                <a:spcPts val="1000"/>
+              </a:spcAft>
+            </a:pPr>
+            <a:r>
+              <a:rPr sz="1800" b="1">
+                <a:solidFill>
+                  <a:srgbClr val="1A1D27"/>
+                </a:solidFill>
+                <a:latin typeface="Calibri"/>
+              </a:rPr>
+              <a:t>▸  It's human-in-the-loop by design -- every flag carries an exact way back to the page a person needs to look at</a:t>
+            </a:r>
+          </a:p>
+          <a:p>
+            <a:pPr>
+              <a:spcAft>
+                <a:spcPts val="1000"/>
+              </a:spcAft>
+            </a:pPr>
+            <a:r>
+              <a:rPr sz="1800" b="1">
+                <a:solidFill>
+                  <a:srgbClr val="1A1D27"/>
+                </a:solidFill>
+                <a:latin typeface="Calibri"/>
+              </a:rPr>
+              <a:t>▸  It scales past hand-checking every document -- targeted review of what's flagged, random audits of what isn't, once the corpus is bigger than 3 files</a:t>
+            </a:r>
+          </a:p>
+          <a:p>
+            <a:pPr>
+              <a:spcAft>
+                <a:spcPts val="1000"/>
+              </a:spcAft>
+            </a:pPr>
+            <a:r>
+              <a:rPr sz="1800" b="1">
+                <a:solidFill>
+                  <a:srgbClr val="1A1D27"/>
+                </a:solidFill>
+                <a:latin typeface="Calibri"/>
+              </a:rPr>
+              <a:t>▸  Next: Module 3 takes this same validated output and turns it into retrieval-ready chunks -- recursive, semantic, and hierarchical strategies, compared on the same real documents</a:t>
+            </a:r>
+          </a:p>
+        </p:txBody>
+      </p:sp>
+      <p:sp>
+        <p:nvSpPr>
+          <p:cNvPr id="6" name="TextBox 5"/>
+          <p:cNvSpPr txBox="1"/>
+          <p:nvPr/>
+        </p:nvSpPr>
+        <p:spPr>
+          <a:xfrm>
+            <a:off x="11521440" y="6446520"/>
+            <a:ext cx="548640" cy="320040"/>
+          </a:xfrm>
+          <a:prstGeom prst="rect">
+            <a:avLst/>
+          </a:prstGeom>
+          <a:noFill/>
+        </p:spPr>
+        <p:txBody>
+          <a:bodyPr wrap="square">
+            <a:spAutoFit/>
+          </a:bodyPr>
+          <a:lstStyle/>
+          <a:p>
+            <a:pPr algn="r"/>
+            <a:r>
+              <a:rPr sz="1100" b="0" i="0">
+                <a:solidFill>
+                  <a:srgbClr val="5B6374"/>
+                </a:solidFill>
+                <a:latin typeface="Calibri"/>
+              </a:rPr>
+              <a:t>15</a:t>
+            </a:r>
+          </a:p>
+        </p:txBody>
+      </p:sp>
+    </p:spTree>
+  </p:cSld>
+  <p:clrMapOvr>
+    <a:masterClrMapping/>
+  </p:clrMapOvr>
+</p:sld>
+</file>
+
+<file path=ppt/slides/slide16.xml><?xml version="1.0" encoding="utf-8"?>
 <p:sld xmlns:a="http://schemas.openxmlformats.org/drawingml/2006/main" xmlns:p="http://schemas.openxmlformats.org/presentationml/2006/main" xmlns:r="http://schemas.openxmlformats.org/officeDocument/2006/relationships">
   <p:cSld>
     <p:bg>
@@ -6600,7 +7223,7 @@
                 </a:solidFill>
                 <a:latin typeface="Calibri"/>
               </a:rPr>
-              <a:t>WHAT ELSE GETS MEASURED</a:t>
+              <a:t>LAYOUT ANALYSIS</a:t>
             </a:r>
           </a:p>
         </p:txBody>
@@ -6635,7 +7258,7 @@
                 </a:solidFill>
                 <a:latin typeface="Calibri"/>
               </a:rPr>
-              <a:t>Beyond Just Tokens</a:t>
+              <a:t>The Other Half of Validation</a:t>
             </a:r>
           </a:p>
         </p:txBody>
@@ -6664,81 +7287,97 @@
           <a:p>
             <a:pPr>
               <a:spcAft>
-                <a:spcPts val="1200"/>
+                <a:spcPts val="1000"/>
               </a:spcAft>
             </a:pPr>
             <a:r>
-              <a:rPr sz="2000" b="1">
+              <a:rPr sz="1800" b="1">
                 <a:solidFill>
                   <a:srgbClr val="1A1D27"/>
                 </a:solidFill>
                 <a:latin typeface="Calibri"/>
               </a:rPr>
-              <a:t>▸  How many images and tables actually made it into the extracted text, versus what the source document had</a:t>
+              <a:t>▸  Token counting tells you how much content came out. It says nothing about whether the layout detector actually understood the page</a:t>
             </a:r>
           </a:p>
           <a:p>
             <a:pPr>
               <a:spcAft>
-                <a:spcPts val="1200"/>
+                <a:spcPts val="1000"/>
               </a:spcAft>
             </a:pPr>
             <a:r>
-              <a:rPr sz="2000" b="1">
+              <a:rPr sz="1800" b="1">
                 <a:solidFill>
                   <a:srgbClr val="1A1D27"/>
                 </a:solidFill>
                 <a:latin typeface="Calibri"/>
               </a:rPr>
-              <a:t>▸  How many logos, signatures, stamps/seals, and other visual artifacts were detected, and where</a:t>
+              <a:t>▸  Module 1's layout detector already assigns a confidence score to every region it finds -- Module 2 doesn't compute this, it surfaces what already exists</a:t>
             </a:r>
           </a:p>
           <a:p>
             <a:pPr>
               <a:spcAft>
-                <a:spcPts val="1200"/>
+                <a:spcPts val="500"/>
               </a:spcAft>
             </a:pPr>
             <a:r>
-              <a:rPr sz="2000" b="1">
-                <a:solidFill>
-                  <a:srgbClr val="1A1D27"/>
-                </a:solidFill>
-                <a:latin typeface="Calibri"/>
-              </a:rPr>
-              <a:t>▸  How many regions the layout detector itself flagged as uncertain -- it wasn't sure what it was looking at</a:t>
+              <a:rPr sz="1500" b="0">
+                <a:solidFill>
+                  <a:srgbClr val="5B6374"/>
+                </a:solidFill>
+                <a:latin typeface="Calibri"/>
+              </a:rPr>
+              <a:t>     –  low_confidence_regions -- the detector found something there, but wasn't sure what</a:t>
             </a:r>
           </a:p>
           <a:p>
             <a:pPr>
               <a:spcAft>
-                <a:spcPts val="1200"/>
+                <a:spcPts val="500"/>
               </a:spcAft>
             </a:pPr>
             <a:r>
-              <a:rPr sz="2000" b="1">
-                <a:solidFill>
-                  <a:srgbClr val="1A1D27"/>
-                </a:solidFill>
-                <a:latin typeface="Calibri"/>
-              </a:rPr>
-              <a:t>▸  How many regions were dropped entirely and excluded from the document -- some correctly (headers/footers), some not</a:t>
+              <a:rPr sz="1500" b="0">
+                <a:solidFill>
+                  <a:srgbClr val="5B6374"/>
+                </a:solidFill>
+                <a:latin typeface="Calibri"/>
+              </a:rPr>
+              <a:t>     –  dropped_regions -- the detector excluded a region entirely: correctly (headers/footers), or not (see the case study ahead)</a:t>
             </a:r>
           </a:p>
           <a:p>
             <a:pPr>
               <a:spcAft>
-                <a:spcPts val="1200"/>
+                <a:spcPts val="1000"/>
               </a:spcAft>
             </a:pPr>
             <a:r>
-              <a:rPr sz="2000" b="1">
+              <a:rPr sz="1800" b="1">
                 <a:solidFill>
                   <a:srgbClr val="1A1D27"/>
                 </a:solidFill>
                 <a:latin typeface="Calibri"/>
               </a:rPr>
-              <a:t>▸  How many tables came out structurally broken -- malformed, not just imperfect</a:t>
+              <a:t>▸  Same source also covers artifacts (logos, signatures, stamp/seals) and malformed tables -- structural failures, not content-volume ones</a:t>
+            </a:r>
+          </a:p>
+          <a:p>
+            <a:pPr>
+              <a:spcAft>
+                <a:spcPts val="1000"/>
+              </a:spcAft>
+            </a:pPr>
+            <a:r>
+              <a:rPr sz="1800" b="1">
+                <a:solidFill>
+                  <a:srgbClr val="1A1D27"/>
+                </a:solidFill>
+                <a:latin typeface="Calibri"/>
+              </a:rPr>
+              <a:t>▸  Two independent questions: token analysis asks “how much came out,” layout analysis asks “did it even see the page correctly”</a:t>
             </a:r>
           </a:p>
         </p:txBody>

</xml_diff>

<commit_message>
Split dense token and sampling slides into lighter, single-topic ones
The token slide (3 ideas crammed into one) and the sampling slide (6
bullets plus sub-bullets plus a note) were both trying to cover too much
per slide. Split into 3 token slides (words-vs-tokens, why it matters,
how it's counted) and 4 sampling slides (the scaling problem, targeted
review, random audits, putting it together as one rule) -- no slide-count
constraint, so each one now covers a single idea.

Co-Authored-By: Claude Sonnet 5 <noreply@anthropic.com>
</commit_message>
<xml_diff>
--- a/2. ANALYSIS/Analysis_Module_Overview.pptx
+++ b/2. ANALYSIS/Analysis_Module_Overview.pptx
@@ -21,6 +21,11 @@
     <p:sldId id="269" r:id="rId20"/>
     <p:sldId id="270" r:id="rId21"/>
     <p:sldId id="271" r:id="rId22"/>
+    <p:sldId id="272" r:id="rId23"/>
+    <p:sldId id="273" r:id="rId24"/>
+    <p:sldId id="274" r:id="rId25"/>
+    <p:sldId id="275" r:id="rId26"/>
+    <p:sldId id="276" r:id="rId27"/>
   </p:sldIdLst>
   <p:sldSz cx="12191695" cy="6858000" type="screen4x3"/>
   <p:notesSz cx="6858000" cy="9144000"/>
@@ -3335,7 +3340,7 @@
             <a:avLst/>
           </a:prstGeom>
           <a:solidFill>
-            <a:srgbClr val="E06C5C"/>
+            <a:srgbClr val="3E8EDE"/>
           </a:solidFill>
           <a:ln>
             <a:noFill/>
@@ -3389,11 +3394,11 @@
             <a:r>
               <a:rPr sz="1500" b="1" i="0">
                 <a:solidFill>
-                  <a:srgbClr val="E06C5C"/>
-                </a:solidFill>
-                <a:latin typeface="Calibri"/>
-              </a:rPr>
-              <a:t>ROOT CAUSE ANALYSIS</a:t>
+                  <a:srgbClr val="3E8EDE"/>
+                </a:solidFill>
+                <a:latin typeface="Calibri"/>
+              </a:rPr>
+              <a:t>LAYOUT ANALYSIS</a:t>
             </a:r>
           </a:p>
         </p:txBody>
@@ -3428,7 +3433,7 @@
                 </a:solidFill>
                 <a:latin typeface="Calibri"/>
               </a:rPr>
-              <a:t>Tracing a Dropped Region Back to a Real Bug</a:t>
+              <a:t>The Other Half of Validation</a:t>
             </a:r>
           </a:p>
         </p:txBody>
@@ -3457,65 +3462,97 @@
           <a:p>
             <a:pPr>
               <a:spcAft>
-                <a:spcPts val="1200"/>
+                <a:spcPts val="1000"/>
               </a:spcAft>
             </a:pPr>
             <a:r>
-              <a:rPr sz="2000" b="1">
+              <a:rPr sz="1800" b="1">
                 <a:solidFill>
                   <a:srgbClr val="1A1D27"/>
                 </a:solidFill>
                 <a:latin typeface="Calibri"/>
               </a:rPr>
-              <a:t>▸  One document's Dropped Regions sheet flagged a region: low confidence, a specific location on the page</a:t>
+              <a:t>▸  Token counting tells you how much content came out. It says nothing about whether the layout detector actually understood the page</a:t>
             </a:r>
           </a:p>
           <a:p>
             <a:pPr>
               <a:spcAft>
-                <a:spcPts val="1200"/>
+                <a:spcPts val="1000"/>
               </a:spcAft>
             </a:pPr>
             <a:r>
-              <a:rPr sz="2000" b="1">
+              <a:rPr sz="1800" b="1">
                 <a:solidFill>
                   <a:srgbClr val="1A1D27"/>
                 </a:solidFill>
                 <a:latin typeface="Calibri"/>
               </a:rPr>
-              <a:t>▸  That location turned out to be the document's logo -- a real image the layout detector misclassified as page furniture and dropped before extraction ever saw it</a:t>
+              <a:t>▸  Module 1's layout detector already assigns a confidence score to every region it finds -- Module 2 doesn't compute this, it surfaces what already exists</a:t>
             </a:r>
           </a:p>
           <a:p>
             <a:pPr>
               <a:spcAft>
-                <a:spcPts val="1200"/>
+                <a:spcPts val="500"/>
               </a:spcAft>
             </a:pPr>
             <a:r>
-              <a:rPr sz="2000" b="1">
-                <a:solidFill>
-                  <a:srgbClr val="1A1D27"/>
-                </a:solidFill>
-                <a:latin typeface="Calibri"/>
-              </a:rPr>
-              <a:t>▸  Looking at that exact location on the original page image confirmed it immediately -- a visible box drawn right over the logo</a:t>
+              <a:rPr sz="1500" b="0">
+                <a:solidFill>
+                  <a:srgbClr val="5B6374"/>
+                </a:solidFill>
+                <a:latin typeface="Calibri"/>
+              </a:rPr>
+              <a:t>     –  low_confidence_regions -- the detector found something there, but wasn't sure what</a:t>
             </a:r>
           </a:p>
           <a:p>
             <a:pPr>
               <a:spcAft>
-                <a:spcPts val="600"/>
+                <a:spcPts val="500"/>
               </a:spcAft>
             </a:pPr>
             <a:r>
-              <a:rPr sz="1600" b="0">
+              <a:rPr sz="1500" b="0">
                 <a:solidFill>
                   <a:srgbClr val="5B6374"/>
                 </a:solidFill>
                 <a:latin typeface="Calibri"/>
               </a:rPr>
-              <a:t>     –  This is the whole point of keeping every dropped region instead of silently discarding them -- it turns a hidden bug into something traceable, and something fixable</a:t>
+              <a:t>     –  dropped_regions -- the detector excluded a region entirely: correctly (headers/footers), or not (see the case study ahead)</a:t>
+            </a:r>
+          </a:p>
+          <a:p>
+            <a:pPr>
+              <a:spcAft>
+                <a:spcPts val="1000"/>
+              </a:spcAft>
+            </a:pPr>
+            <a:r>
+              <a:rPr sz="1800" b="1">
+                <a:solidFill>
+                  <a:srgbClr val="1A1D27"/>
+                </a:solidFill>
+                <a:latin typeface="Calibri"/>
+              </a:rPr>
+              <a:t>▸  Same source also covers artifacts (logos, signatures, stamp/seals) and malformed tables -- structural failures, not content-volume ones</a:t>
+            </a:r>
+          </a:p>
+          <a:p>
+            <a:pPr>
+              <a:spcAft>
+                <a:spcPts val="1000"/>
+              </a:spcAft>
+            </a:pPr>
+            <a:r>
+              <a:rPr sz="1800" b="1">
+                <a:solidFill>
+                  <a:srgbClr val="1A1D27"/>
+                </a:solidFill>
+                <a:latin typeface="Calibri"/>
+              </a:rPr>
+              <a:t>▸  Two independent questions: token analysis asks “how much came out,” layout analysis asks “did it even see the page correctly”</a:t>
             </a:r>
           </a:p>
         </p:txBody>
@@ -3654,7 +3691,7 @@
                 </a:solidFill>
                 <a:latin typeface="Calibri"/>
               </a:rPr>
-              <a:t>HUMAN-IN-THE-LOOP, BY DESIGN</a:t>
+              <a:t>THE DELIVERABLE</a:t>
             </a:r>
           </a:p>
         </p:txBody>
@@ -3689,7 +3726,7 @@
                 </a:solidFill>
                 <a:latin typeface="Calibri"/>
               </a:rPr>
-              <a:t>A Flag Is Only Useful If Someone Can Act On It</a:t>
+              <a:t>One Workbook, Built for Validation</a:t>
             </a:r>
           </a:p>
         </p:txBody>
@@ -3718,81 +3755,81 @@
           <a:p>
             <a:pPr>
               <a:spcAft>
-                <a:spcPts val="1000"/>
+                <a:spcPts val="1200"/>
               </a:spcAft>
             </a:pPr>
             <a:r>
-              <a:rPr sz="1800" b="1">
+              <a:rPr sz="2000" b="1">
                 <a:solidFill>
                   <a:srgbClr val="1A1D27"/>
                 </a:solidFill>
                 <a:latin typeface="Calibri"/>
               </a:rPr>
-              <a:t>▸  Every flagged row -- low confidence, dropped region, malformed table -- carries a page number and a bounding box back to the original document</a:t>
+              <a:t>▸  Summary -- one row per document, every stat from the last two slides in one place, built to be scanned fast</a:t>
             </a:r>
           </a:p>
           <a:p>
             <a:pPr>
               <a:spcAft>
-                <a:spcPts val="1000"/>
+                <a:spcPts val="1200"/>
               </a:spcAft>
             </a:pPr>
             <a:r>
-              <a:rPr sz="1800" b="1">
+              <a:rPr sz="2000" b="1">
                 <a:solidFill>
                   <a:srgbClr val="1A1D27"/>
                 </a:solidFill>
                 <a:latin typeface="Calibri"/>
               </a:rPr>
-              <a:t>▸  That's not incidental: it's what turns a flag into a 30-second check instead of a full re-read of the document</a:t>
+              <a:t>▸  Artifacts Detail -- one row per detected logo/signature/stamp: page, description, exact location</a:t>
             </a:r>
           </a:p>
           <a:p>
             <a:pPr>
               <a:spcAft>
-                <a:spcPts val="1000"/>
+                <a:spcPts val="1200"/>
               </a:spcAft>
             </a:pPr>
             <a:r>
-              <a:rPr sz="1800" b="1">
+              <a:rPr sz="2000" b="1">
                 <a:solidFill>
                   <a:srgbClr val="1A1D27"/>
                 </a:solidFill>
                 <a:latin typeface="Calibri"/>
               </a:rPr>
-              <a:t>▸  The loop: detector flags an uncertain region → it lands in the Excel workbook → a person looks at that exact spot on the original page → confirms a real problem, or clears it as a false alarm</a:t>
+              <a:t>▸  Low Confidence Regions -- one row per region the layout detector wasn't sure about</a:t>
             </a:r>
           </a:p>
           <a:p>
             <a:pPr>
               <a:spcAft>
-                <a:spcPts val="500"/>
+                <a:spcPts val="1200"/>
               </a:spcAft>
             </a:pPr>
             <a:r>
-              <a:rPr sz="1500" b="0">
-                <a:solidFill>
-                  <a:srgbClr val="5B6374"/>
-                </a:solidFill>
-                <a:latin typeface="Calibri"/>
-              </a:rPr>
-              <a:t>     –  The logo case study on the previous slide is this loop working end to end -- a two-minute human check catching a bug automation alone missed</a:t>
+              <a:rPr sz="2000" b="1">
+                <a:solidFill>
+                  <a:srgbClr val="1A1D27"/>
+                </a:solidFill>
+                <a:latin typeface="Calibri"/>
+              </a:rPr>
+              <a:t>▸  Dropped Regions -- one row per region excluded from the document, including anything misclassified and dropped by mistake</a:t>
             </a:r>
           </a:p>
           <a:p>
             <a:pPr>
               <a:spcAft>
-                <a:spcPts val="1000"/>
+                <a:spcPts val="600"/>
               </a:spcAft>
             </a:pPr>
             <a:r>
-              <a:rPr sz="1800" b="1">
-                <a:solidFill>
-                  <a:srgbClr val="1A1D27"/>
-                </a:solidFill>
-                <a:latin typeface="Calibri"/>
-              </a:rPr>
-              <a:t>▸  What this module doesn't do yet: feed a human's correction back into re-thresholding or retraining the detector -- that's the natural next step, not built here</a:t>
+              <a:rPr sz="1600" b="0">
+                <a:solidFill>
+                  <a:srgbClr val="5B6374"/>
+                </a:solidFill>
+                <a:latin typeface="Calibri"/>
+              </a:rPr>
+              <a:t>     –  Every flagged row carries a location back to the original page -- a finding is only useful if it can be checked</a:t>
             </a:r>
           </a:p>
         </p:txBody>
@@ -3873,7 +3910,7 @@
             <a:avLst/>
           </a:prstGeom>
           <a:solidFill>
-            <a:srgbClr val="3E8EDE"/>
+            <a:srgbClr val="E06C5C"/>
           </a:solidFill>
           <a:ln>
             <a:noFill/>
@@ -3927,11 +3964,11 @@
             <a:r>
               <a:rPr sz="1500" b="1" i="0">
                 <a:solidFill>
-                  <a:srgbClr val="3E8EDE"/>
-                </a:solidFill>
-                <a:latin typeface="Calibri"/>
-              </a:rPr>
-              <a:t>A VALIDATION HABIT</a:t>
+                  <a:srgbClr val="E06C5C"/>
+                </a:solidFill>
+                <a:latin typeface="Calibri"/>
+              </a:rPr>
+              <a:t>ROOT CAUSE ANALYSIS</a:t>
             </a:r>
           </a:p>
         </p:txBody>
@@ -3966,7 +4003,7 @@
                 </a:solidFill>
                 <a:latin typeface="Calibri"/>
               </a:rPr>
-              <a:t>Tokens/Page as an Anomaly Signal</a:t>
+              <a:t>Tracing a Dropped Region Back to a Real Bug</a:t>
             </a:r>
           </a:p>
         </p:txBody>
@@ -4005,7 +4042,7 @@
                 </a:solidFill>
                 <a:latin typeface="Calibri"/>
               </a:rPr>
-              <a:t>▸  There's no universal “correct” tokens-per-page number -- it depends entirely on the document type</a:t>
+              <a:t>▸  One document's Dropped Regions sheet flagged a region: low confidence, a specific location on the page</a:t>
             </a:r>
           </a:p>
           <a:p>
@@ -4021,7 +4058,23 @@
                 </a:solidFill>
                 <a:latin typeface="Calibri"/>
               </a:rPr>
-              <a:t>▸  But once you have it for a batch of similar documents, an outlier is worth a look:</a:t>
+              <a:t>▸  That location turned out to be the document's logo -- a real image the layout detector misclassified as page furniture and dropped before extraction ever saw it</a:t>
+            </a:r>
+          </a:p>
+          <a:p>
+            <a:pPr>
+              <a:spcAft>
+                <a:spcPts val="1200"/>
+              </a:spcAft>
+            </a:pPr>
+            <a:r>
+              <a:rPr sz="2000" b="1">
+                <a:solidFill>
+                  <a:srgbClr val="1A1D27"/>
+                </a:solidFill>
+                <a:latin typeface="Calibri"/>
+              </a:rPr>
+              <a:t>▸  Looking at that exact location on the original page image confirmed it immediately -- a visible box drawn right over the logo</a:t>
             </a:r>
           </a:p>
           <a:p>
@@ -4037,39 +4090,7 @@
                 </a:solidFill>
                 <a:latin typeface="Calibri"/>
               </a:rPr>
-              <a:t>     –  Much LOWER than its peers -- possible sign of missed or truncated content</a:t>
-            </a:r>
-          </a:p>
-          <a:p>
-            <a:pPr>
-              <a:spcAft>
-                <a:spcPts val="600"/>
-              </a:spcAft>
-            </a:pPr>
-            <a:r>
-              <a:rPr sz="1600" b="0">
-                <a:solidFill>
-                  <a:srgbClr val="5B6374"/>
-                </a:solidFill>
-                <a:latin typeface="Calibri"/>
-              </a:rPr>
-              <a:t>     –  Much HIGHER than its peers -- possible sign of garbled or repeated extraction output</a:t>
-            </a:r>
-          </a:p>
-          <a:p>
-            <a:pPr>
-              <a:spcAft>
-                <a:spcPts val="1200"/>
-              </a:spcAft>
-            </a:pPr>
-            <a:r>
-              <a:rPr sz="2000" b="1">
-                <a:solidFill>
-                  <a:srgbClr val="1A1D27"/>
-                </a:solidFill>
-                <a:latin typeface="Calibri"/>
-              </a:rPr>
-              <a:t>▸  The value isn't any single number -- it's being able to scan 50 rows and immediately see which ones don't look like the rest</a:t>
+              <a:t>     –  This is the whole point of keeping every dropped region instead of silently discarding them -- it turns a hidden bug into something traceable, and something fixable</a:t>
             </a:r>
           </a:p>
         </p:txBody>
@@ -4208,7 +4229,7 @@
                 </a:solidFill>
                 <a:latin typeface="Calibri"/>
               </a:rPr>
-              <a:t>SAMPLING AT SCALE</a:t>
+              <a:t>HUMAN-IN-THE-LOOP, BY DESIGN</a:t>
             </a:r>
           </a:p>
         </p:txBody>
@@ -4243,7 +4264,7 @@
                 </a:solidFill>
                 <a:latin typeface="Calibri"/>
               </a:rPr>
-              <a:t>From 3 Documents to 3,000</a:t>
+              <a:t>A Flag Is Only Useful If Someone Can Act On It</a:t>
             </a:r>
           </a:p>
         </p:txBody>
@@ -4272,97 +4293,81 @@
           <a:p>
             <a:pPr>
               <a:spcAft>
-                <a:spcPts val="800"/>
+                <a:spcPts val="1000"/>
               </a:spcAft>
             </a:pPr>
             <a:r>
-              <a:rPr sz="1600" b="1">
+              <a:rPr sz="1800" b="1">
                 <a:solidFill>
                   <a:srgbClr val="1A1D27"/>
                 </a:solidFill>
                 <a:latin typeface="Calibri"/>
               </a:rPr>
-              <a:t>▸  This module's corpus is 3 real documents -- reviewing every flagged row by hand is trivial at that size. It stops being trivial well before you reach a few thousand</a:t>
+              <a:t>▸  Every flagged row -- low confidence, dropped region, malformed table -- carries a page number and a bounding box back to the original document</a:t>
             </a:r>
           </a:p>
           <a:p>
             <a:pPr>
               <a:spcAft>
-                <a:spcPts val="800"/>
+                <a:spcPts val="1000"/>
               </a:spcAft>
             </a:pPr>
             <a:r>
-              <a:rPr sz="1600" b="1">
+              <a:rPr sz="1800" b="1">
                 <a:solidFill>
                   <a:srgbClr val="1A1D27"/>
                 </a:solidFill>
                 <a:latin typeface="Calibri"/>
               </a:rPr>
-              <a:t>▸  The fix isn't reviewing everything, and it isn't reviewing a random handful either -- it's spending human attention where the model already told you it's unsure</a:t>
+              <a:t>▸  That's not incidental: it's what turns a flag into a 30-second check instead of a full re-read of the document</a:t>
             </a:r>
           </a:p>
           <a:p>
             <a:pPr>
               <a:spcAft>
-                <a:spcPts val="400"/>
+                <a:spcPts val="1000"/>
               </a:spcAft>
             </a:pPr>
             <a:r>
-              <a:rPr sz="1300" b="0">
-                <a:solidFill>
-                  <a:srgbClr val="5B6374"/>
-                </a:solidFill>
-                <a:latin typeface="Calibri"/>
-              </a:rPr>
-              <a:t>     –  Targeted review, 100% coverage -- every document with any low-confidence region, dropped region, or malformed table. Usually a small minority of the corpus, which is exactly why full coverage stays affordable</a:t>
+              <a:rPr sz="1800" b="1">
+                <a:solidFill>
+                  <a:srgbClr val="1A1D27"/>
+                </a:solidFill>
+                <a:latin typeface="Calibri"/>
+              </a:rPr>
+              <a:t>▸  The loop: detector flags an uncertain region → it lands in the Excel workbook → a person looks at that exact spot on the original page → confirms a real problem, or clears it as a false alarm</a:t>
             </a:r>
           </a:p>
           <a:p>
             <a:pPr>
               <a:spcAft>
-                <a:spcPts val="400"/>
+                <a:spcPts val="500"/>
               </a:spcAft>
             </a:pPr>
             <a:r>
-              <a:rPr sz="1300" b="0">
+              <a:rPr sz="1500" b="0">
                 <a:solidFill>
                   <a:srgbClr val="5B6374"/>
                 </a:solidFill>
                 <a:latin typeface="Calibri"/>
               </a:rPr>
-              <a:t>     –  Random audit sample of the rest -- a small percentage (5-10% is a common starting point) of documents that came back with zero flags, specifically to catch cases where the detector is confidently wrong</a:t>
+              <a:t>     –  The logo case study on the previous slide is this loop working end to end -- a two-minute human check catching a bug automation alone missed</a:t>
             </a:r>
           </a:p>
           <a:p>
             <a:pPr>
               <a:spcAft>
-                <a:spcPts val="800"/>
+                <a:spcPts val="1000"/>
               </a:spcAft>
             </a:pPr>
             <a:r>
-              <a:rPr sz="1600" b="1">
+              <a:rPr sz="1800" b="1">
                 <a:solidFill>
                   <a:srgbClr val="1A1D27"/>
                 </a:solidFill>
                 <a:latin typeface="Calibri"/>
               </a:rPr>
-              <a:t>▸  Why the second bucket matters: a validation system that only ever double-checks its own doubts can't catch its own blind spots -- the audit sample is how you find out if “zero flags” is actually trustworthy</a:t>
-            </a:r>
-          </a:p>
-          <a:p>
-            <a:pPr>
-              <a:spcAft>
-                <a:spcPts val="800"/>
-              </a:spcAft>
-            </a:pPr>
-            <a:r>
-              <a:rPr sz="1600" b="1">
-                <a:solidFill>
-                  <a:srgbClr val="1A1D27"/>
-                </a:solidFill>
-                <a:latin typeface="Calibri"/>
-              </a:rPr>
-              <a:t>▸  Tokens/page outliers (previous slide) feed the same triage -- an outlier is one more reason to pull a document into the reviewed set even with zero layout flags</a:t>
+              <a:t>▸  What this module doesn't do yet: feed a human's correction back into re-thresholding or retraining the detector -- that's the natural next step, not built here</a:t>
             </a:r>
           </a:p>
         </p:txBody>
@@ -4370,41 +4375,6 @@
       <p:sp>
         <p:nvSpPr>
           <p:cNvPr id="6" name="TextBox 5"/>
-          <p:cNvSpPr txBox="1"/>
-          <p:nvPr/>
-        </p:nvSpPr>
-        <p:spPr>
-          <a:xfrm>
-            <a:off x="731520" y="6263640"/>
-            <a:ext cx="10698480" cy="411480"/>
-          </a:xfrm>
-          <a:prstGeom prst="rect">
-            <a:avLst/>
-          </a:prstGeom>
-          <a:noFill/>
-        </p:spPr>
-        <p:txBody>
-          <a:bodyPr wrap="square">
-            <a:spAutoFit/>
-          </a:bodyPr>
-          <a:lstStyle/>
-          <a:p>
-            <a:pPr algn="l"/>
-            <a:r>
-              <a:rPr sz="1200" b="0" i="1">
-                <a:solidFill>
-                  <a:srgbClr val="5B6374"/>
-                </a:solidFill>
-                <a:latin typeface="Calibri"/>
-              </a:rPr>
-              <a:t>This is methodology, not a result -- honest about what a 3-document teaching corpus can and can't demonstrate. The same low_confidence_count / dropped_region_count / tokens_per_page columns already in the Excel report are exactly what a sampling rule would key off of at real scale.</a:t>
-            </a:r>
-          </a:p>
-        </p:txBody>
-      </p:sp>
-      <p:sp>
-        <p:nvSpPr>
-          <p:cNvPr id="7" name="TextBox 6"/>
           <p:cNvSpPr txBox="1"/>
           <p:nvPr/>
         </p:nvSpPr>
@@ -4536,7 +4506,7 @@
                 </a:solidFill>
                 <a:latin typeface="Calibri"/>
               </a:rPr>
-              <a:t>A QUIET DETAIL</a:t>
+              <a:t>A VALIDATION HABIT</a:t>
             </a:r>
           </a:p>
         </p:txBody>
@@ -4571,7 +4541,7 @@
                 </a:solidFill>
                 <a:latin typeface="Calibri"/>
               </a:rPr>
-              <a:t>Partial Runs Get Skipped, Not Guessed At</a:t>
+              <a:t>Tokens/Page as an Anomaly Signal</a:t>
             </a:r>
           </a:p>
         </p:txBody>
@@ -4610,7 +4580,7 @@
                 </a:solidFill>
                 <a:latin typeface="Calibri"/>
               </a:rPr>
-              <a:t>▸  A document only gets analyzed once its extraction has actually finished, not while it's still in progress</a:t>
+              <a:t>▸  There's no universal “correct” tokens-per-page number -- it depends entirely on the document type</a:t>
             </a:r>
           </a:p>
           <a:p>
@@ -4626,7 +4596,39 @@
                 </a:solidFill>
                 <a:latin typeface="Calibri"/>
               </a:rPr>
-              <a:t>▸  An interrupted or still-running extraction leaves incomplete output</a:t>
+              <a:t>▸  But once you have it for a batch of similar documents, an outlier is worth a look:</a:t>
+            </a:r>
+          </a:p>
+          <a:p>
+            <a:pPr>
+              <a:spcAft>
+                <a:spcPts val="600"/>
+              </a:spcAft>
+            </a:pPr>
+            <a:r>
+              <a:rPr sz="1600" b="0">
+                <a:solidFill>
+                  <a:srgbClr val="5B6374"/>
+                </a:solidFill>
+                <a:latin typeface="Calibri"/>
+              </a:rPr>
+              <a:t>     –  Much LOWER than its peers -- possible sign of missed or truncated content</a:t>
+            </a:r>
+          </a:p>
+          <a:p>
+            <a:pPr>
+              <a:spcAft>
+                <a:spcPts val="600"/>
+              </a:spcAft>
+            </a:pPr>
+            <a:r>
+              <a:rPr sz="1600" b="0">
+                <a:solidFill>
+                  <a:srgbClr val="5B6374"/>
+                </a:solidFill>
+                <a:latin typeface="Calibri"/>
+              </a:rPr>
+              <a:t>     –  Much HIGHER than its peers -- possible sign of garbled or repeated extraction output</a:t>
             </a:r>
           </a:p>
           <a:p>
@@ -4642,7 +4644,7 @@
                 </a:solidFill>
                 <a:latin typeface="Calibri"/>
               </a:rPr>
-              <a:t>▸  That incomplete output gets skipped rather than guessed at -- a document either finished cleanly, or it isn't validated at all</a:t>
+              <a:t>▸  The value isn't any single number -- it's being able to scan 50 rows and immediately see which ones don't look like the rest</a:t>
             </a:r>
           </a:p>
         </p:txBody>
@@ -4781,7 +4783,7 @@
                 </a:solidFill>
                 <a:latin typeface="Calibri"/>
               </a:rPr>
-              <a:t>WRAP-UP</a:t>
+              <a:t>THE SCALING PROBLEM</a:t>
             </a:r>
           </a:p>
         </p:txBody>
@@ -4816,7 +4818,7 @@
                 </a:solidFill>
                 <a:latin typeface="Calibri"/>
               </a:rPr>
-              <a:t>Why This Module Matters</a:t>
+              <a:t>Reviewing Everything Doesn't Scale</a:t>
             </a:r>
           </a:p>
         </p:txBody>
@@ -4845,81 +4847,49 @@
           <a:p>
             <a:pPr>
               <a:spcAft>
-                <a:spcPts val="1000"/>
+                <a:spcPts val="1200"/>
               </a:spcAft>
             </a:pPr>
             <a:r>
-              <a:rPr sz="1800" b="1">
+              <a:rPr sz="2000" b="1">
                 <a:solidFill>
                   <a:srgbClr val="1A1D27"/>
                 </a:solidFill>
                 <a:latin typeface="Calibri"/>
               </a:rPr>
-              <a:t>▸  It turns “the pipeline didn't crash” into “here's proof this document is actually usable”</a:t>
+              <a:t>▸  This module's corpus is 3 real documents -- reviewing every flagged row by hand is trivial at that size</a:t>
             </a:r>
           </a:p>
           <a:p>
             <a:pPr>
               <a:spcAft>
-                <a:spcPts val="1000"/>
+                <a:spcPts val="1200"/>
               </a:spcAft>
             </a:pPr>
             <a:r>
-              <a:rPr sz="1800" b="1">
+              <a:rPr sz="2000" b="1">
                 <a:solidFill>
                   <a:srgbClr val="1A1D27"/>
                 </a:solidFill>
                 <a:latin typeface="Calibri"/>
               </a:rPr>
-              <a:t>▸  Two independent checks, not one -- token analysis for how much came out, layout analysis for whether the model saw the page correctly</a:t>
+              <a:t>▸  That stops being trivial well before you reach a few hundred documents, let alone a few thousand</a:t>
             </a:r>
           </a:p>
           <a:p>
             <a:pPr>
               <a:spcAft>
-                <a:spcPts val="1000"/>
+                <a:spcPts val="1200"/>
               </a:spcAft>
             </a:pPr>
             <a:r>
-              <a:rPr sz="1800" b="1">
+              <a:rPr sz="2000" b="1">
                 <a:solidFill>
                   <a:srgbClr val="1A1D27"/>
                 </a:solidFill>
                 <a:latin typeface="Calibri"/>
               </a:rPr>
-              <a:t>▸  It's human-in-the-loop by design -- every flag carries an exact way back to the page a person needs to look at</a:t>
-            </a:r>
-          </a:p>
-          <a:p>
-            <a:pPr>
-              <a:spcAft>
-                <a:spcPts val="1000"/>
-              </a:spcAft>
-            </a:pPr>
-            <a:r>
-              <a:rPr sz="1800" b="1">
-                <a:solidFill>
-                  <a:srgbClr val="1A1D27"/>
-                </a:solidFill>
-                <a:latin typeface="Calibri"/>
-              </a:rPr>
-              <a:t>▸  It scales past hand-checking every document -- targeted review of what's flagged, random audits of what isn't, once the corpus is bigger than 3 files</a:t>
-            </a:r>
-          </a:p>
-          <a:p>
-            <a:pPr>
-              <a:spcAft>
-                <a:spcPts val="1000"/>
-              </a:spcAft>
-            </a:pPr>
-            <a:r>
-              <a:rPr sz="1800" b="1">
-                <a:solidFill>
-                  <a:srgbClr val="1A1D27"/>
-                </a:solidFill>
-                <a:latin typeface="Calibri"/>
-              </a:rPr>
-              <a:t>▸  Next: Module 3 takes this same validated output and turns it into retrieval-ready chunks -- recursive, semantic, and hierarchical strategies, compared on the same real documents</a:t>
+              <a:t>▸  The fix isn't reviewing everything by hand, and it isn't reviewing a random handful either</a:t>
             </a:r>
           </a:p>
         </p:txBody>
@@ -4973,7 +4943,7 @@
     <p:bg>
       <p:bgPr>
         <a:solidFill>
-          <a:srgbClr val="0F172A"/>
+          <a:srgbClr val="FFFFFF"/>
         </a:solidFill>
         <a:effectLst/>
       </p:bgPr>
@@ -5036,8 +5006,8 @@
         </p:nvSpPr>
         <p:spPr>
           <a:xfrm>
-            <a:off x="914400" y="2743200"/>
-            <a:ext cx="10332720" cy="1097280"/>
+            <a:off x="640080" y="411480"/>
+            <a:ext cx="10881360" cy="457200"/>
           </a:xfrm>
           <a:prstGeom prst="rect">
             <a:avLst/>
@@ -5052,13 +5022,13 @@
           <a:p>
             <a:pPr algn="l"/>
             <a:r>
-              <a:rPr sz="4000" b="1" i="0">
-                <a:solidFill>
-                  <a:srgbClr val="FFFFFF"/>
-                </a:solidFill>
-                <a:latin typeface="Calibri"/>
-              </a:rPr>
-              <a:t>Questions?</a:t>
+              <a:rPr sz="1500" b="1" i="0">
+                <a:solidFill>
+                  <a:srgbClr val="3E8EDE"/>
+                </a:solidFill>
+                <a:latin typeface="Calibri"/>
+              </a:rPr>
+              <a:t>STEP 1: TARGETED REVIEW</a:t>
             </a:r>
           </a:p>
         </p:txBody>
@@ -5071,8 +5041,8 @@
         </p:nvSpPr>
         <p:spPr>
           <a:xfrm>
-            <a:off x="914400" y="3749039"/>
-            <a:ext cx="10332720" cy="1280160"/>
+            <a:off x="640080" y="777240"/>
+            <a:ext cx="10881360" cy="822960"/>
           </a:xfrm>
           <a:prstGeom prst="rect">
             <a:avLst/>
@@ -5087,13 +5057,13 @@
           <a:p>
             <a:pPr algn="l"/>
             <a:r>
-              <a:rPr sz="1800" b="0" i="0">
-                <a:solidFill>
-                  <a:srgbClr val="8A93A6"/>
-                </a:solidFill>
-                <a:latin typeface="Calibri"/>
-              </a:rPr>
-              <a:t>2. ANALYSIS/  --  README.md has the full column-by-column report reference and every real number in this deck.</a:t>
+              <a:rPr sz="3000" b="1" i="0">
+                <a:solidFill>
+                  <a:srgbClr val="1A1D27"/>
+                </a:solidFill>
+                <a:latin typeface="Calibri"/>
+              </a:rPr>
+              <a:t>Full Coverage Where It's Cheap</a:t>
             </a:r>
           </a:p>
         </p:txBody>
@@ -5106,8 +5076,8 @@
         </p:nvSpPr>
         <p:spPr>
           <a:xfrm>
-            <a:off x="914400" y="6126480"/>
-            <a:ext cx="10332720" cy="457200"/>
+            <a:off x="731520" y="1691640"/>
+            <a:ext cx="10698480" cy="4480560"/>
           </a:xfrm>
           <a:prstGeom prst="rect">
             <a:avLst/>
@@ -5120,15 +5090,856 @@
           </a:bodyPr>
           <a:lstStyle/>
           <a:p>
+            <a:pPr>
+              <a:spcAft>
+                <a:spcPts val="1200"/>
+              </a:spcAft>
+            </a:pPr>
+            <a:r>
+              <a:rPr sz="2000" b="1">
+                <a:solidFill>
+                  <a:srgbClr val="1A1D27"/>
+                </a:solidFill>
+                <a:latin typeface="Calibri"/>
+              </a:rPr>
+              <a:t>▸  Review 100% of documents with any low-confidence region, dropped region, or malformed table -- no sampling at all</a:t>
+            </a:r>
+          </a:p>
+          <a:p>
+            <a:pPr>
+              <a:spcAft>
+                <a:spcPts val="1200"/>
+              </a:spcAft>
+            </a:pPr>
+            <a:r>
+              <a:rPr sz="2000" b="1">
+                <a:solidFill>
+                  <a:srgbClr val="1A1D27"/>
+                </a:solidFill>
+                <a:latin typeface="Calibri"/>
+              </a:rPr>
+              <a:t>▸  This bucket is usually a small minority of the corpus, which is exactly why full coverage of it stays affordable even at scale</a:t>
+            </a:r>
+          </a:p>
+          <a:p>
+            <a:pPr>
+              <a:spcAft>
+                <a:spcPts val="1200"/>
+              </a:spcAft>
+            </a:pPr>
+            <a:r>
+              <a:rPr sz="2000" b="1">
+                <a:solidFill>
+                  <a:srgbClr val="1A1D27"/>
+                </a:solidFill>
+                <a:latin typeface="Calibri"/>
+              </a:rPr>
+              <a:t>▸  The model already told you where it's unsure. Step 1 is just not ignoring that signal</a:t>
+            </a:r>
+          </a:p>
+        </p:txBody>
+      </p:sp>
+      <p:sp>
+        <p:nvSpPr>
+          <p:cNvPr id="6" name="TextBox 5"/>
+          <p:cNvSpPr txBox="1"/>
+          <p:nvPr/>
+        </p:nvSpPr>
+        <p:spPr>
+          <a:xfrm>
+            <a:off x="11521440" y="6446520"/>
+            <a:ext cx="548640" cy="320040"/>
+          </a:xfrm>
+          <a:prstGeom prst="rect">
+            <a:avLst/>
+          </a:prstGeom>
+          <a:noFill/>
+        </p:spPr>
+        <p:txBody>
+          <a:bodyPr wrap="square">
+            <a:spAutoFit/>
+          </a:bodyPr>
+          <a:lstStyle/>
+          <a:p>
+            <a:pPr algn="r"/>
+            <a:r>
+              <a:rPr sz="1100" b="0" i="0">
+                <a:solidFill>
+                  <a:srgbClr val="5B6374"/>
+                </a:solidFill>
+                <a:latin typeface="Calibri"/>
+              </a:rPr>
+              <a:t>16</a:t>
+            </a:r>
+          </a:p>
+        </p:txBody>
+      </p:sp>
+    </p:spTree>
+  </p:cSld>
+  <p:clrMapOvr>
+    <a:masterClrMapping/>
+  </p:clrMapOvr>
+</p:sld>
+</file>
+
+<file path=ppt/slides/slide17.xml><?xml version="1.0" encoding="utf-8"?>
+<p:sld xmlns:a="http://schemas.openxmlformats.org/drawingml/2006/main" xmlns:p="http://schemas.openxmlformats.org/presentationml/2006/main" xmlns:r="http://schemas.openxmlformats.org/officeDocument/2006/relationships">
+  <p:cSld>
+    <p:bg>
+      <p:bgPr>
+        <a:solidFill>
+          <a:srgbClr val="FFFFFF"/>
+        </a:solidFill>
+        <a:effectLst/>
+      </p:bgPr>
+    </p:bg>
+    <p:spTree>
+      <p:nvGrpSpPr>
+        <p:cNvPr id="1" name=""/>
+        <p:cNvGrpSpPr/>
+        <p:nvPr/>
+      </p:nvGrpSpPr>
+      <p:grpSpPr/>
+      <p:sp>
+        <p:nvSpPr>
+          <p:cNvPr id="2" name="Rectangle 1"/>
+          <p:cNvSpPr/>
+          <p:nvPr/>
+        </p:nvSpPr>
+        <p:spPr>
+          <a:xfrm>
+            <a:off x="0" y="0"/>
+            <a:ext cx="12191695" cy="109728"/>
+          </a:xfrm>
+          <a:prstGeom prst="rect">
+            <a:avLst/>
+          </a:prstGeom>
+          <a:solidFill>
+            <a:srgbClr val="3E8EDE"/>
+          </a:solidFill>
+          <a:ln>
+            <a:noFill/>
+          </a:ln>
+        </p:spPr>
+        <p:style>
+          <a:lnRef idx="1">
+            <a:schemeClr val="accent1"/>
+          </a:lnRef>
+          <a:fillRef idx="3">
+            <a:schemeClr val="accent1"/>
+          </a:fillRef>
+          <a:effectRef idx="2">
+            <a:schemeClr val="accent1"/>
+          </a:effectRef>
+          <a:fontRef idx="minor">
+            <a:schemeClr val="lt1"/>
+          </a:fontRef>
+        </p:style>
+        <p:txBody>
+          <a:bodyPr rtlCol="0" anchor="ctr"/>
+          <a:lstStyle/>
+          <a:p>
+            <a:pPr algn="ctr"/>
+          </a:p>
+        </p:txBody>
+      </p:sp>
+      <p:sp>
+        <p:nvSpPr>
+          <p:cNvPr id="3" name="TextBox 2"/>
+          <p:cNvSpPr txBox="1"/>
+          <p:nvPr/>
+        </p:nvSpPr>
+        <p:spPr>
+          <a:xfrm>
+            <a:off x="640080" y="411480"/>
+            <a:ext cx="10881360" cy="457200"/>
+          </a:xfrm>
+          <a:prstGeom prst="rect">
+            <a:avLst/>
+          </a:prstGeom>
+          <a:noFill/>
+        </p:spPr>
+        <p:txBody>
+          <a:bodyPr wrap="square">
+            <a:spAutoFit/>
+          </a:bodyPr>
+          <a:lstStyle/>
+          <a:p>
             <a:pPr algn="l"/>
             <a:r>
-              <a:rPr sz="1300" b="0" i="0">
+              <a:rPr sz="1500" b="1" i="0">
+                <a:solidFill>
+                  <a:srgbClr val="3E8EDE"/>
+                </a:solidFill>
+                <a:latin typeface="Calibri"/>
+              </a:rPr>
+              <a:t>STEP 2: RANDOM AUDITS</a:t>
+            </a:r>
+          </a:p>
+        </p:txBody>
+      </p:sp>
+      <p:sp>
+        <p:nvSpPr>
+          <p:cNvPr id="4" name="TextBox 3"/>
+          <p:cNvSpPr txBox="1"/>
+          <p:nvPr/>
+        </p:nvSpPr>
+        <p:spPr>
+          <a:xfrm>
+            <a:off x="640080" y="777240"/>
+            <a:ext cx="10881360" cy="822960"/>
+          </a:xfrm>
+          <a:prstGeom prst="rect">
+            <a:avLst/>
+          </a:prstGeom>
+          <a:noFill/>
+        </p:spPr>
+        <p:txBody>
+          <a:bodyPr wrap="square">
+            <a:spAutoFit/>
+          </a:bodyPr>
+          <a:lstStyle/>
+          <a:p>
+            <a:pPr algn="l"/>
+            <a:r>
+              <a:rPr sz="3000" b="1" i="0">
+                <a:solidFill>
+                  <a:srgbClr val="1A1D27"/>
+                </a:solidFill>
+                <a:latin typeface="Calibri"/>
+              </a:rPr>
+              <a:t>Catching What the Model Didn't Flag</a:t>
+            </a:r>
+          </a:p>
+        </p:txBody>
+      </p:sp>
+      <p:sp>
+        <p:nvSpPr>
+          <p:cNvPr id="5" name="TextBox 4"/>
+          <p:cNvSpPr txBox="1"/>
+          <p:nvPr/>
+        </p:nvSpPr>
+        <p:spPr>
+          <a:xfrm>
+            <a:off x="731520" y="1691640"/>
+            <a:ext cx="10698480" cy="4480560"/>
+          </a:xfrm>
+          <a:prstGeom prst="rect">
+            <a:avLst/>
+          </a:prstGeom>
+          <a:noFill/>
+        </p:spPr>
+        <p:txBody>
+          <a:bodyPr wrap="square">
+            <a:spAutoFit/>
+          </a:bodyPr>
+          <a:lstStyle/>
+          <a:p>
+            <a:pPr>
+              <a:spcAft>
+                <a:spcPts val="1200"/>
+              </a:spcAft>
+            </a:pPr>
+            <a:r>
+              <a:rPr sz="2000" b="1">
+                <a:solidFill>
+                  <a:srgbClr val="1A1D27"/>
+                </a:solidFill>
+                <a:latin typeface="Calibri"/>
+              </a:rPr>
+              <a:t>▸  Pull a small random sample -- 5-10% is a common starting point -- from documents that came back with zero flags</a:t>
+            </a:r>
+          </a:p>
+          <a:p>
+            <a:pPr>
+              <a:spcAft>
+                <a:spcPts val="1200"/>
+              </a:spcAft>
+            </a:pPr>
+            <a:r>
+              <a:rPr sz="2000" b="1">
+                <a:solidFill>
+                  <a:srgbClr val="1A1D27"/>
+                </a:solidFill>
+                <a:latin typeface="Calibri"/>
+              </a:rPr>
+              <a:t>▸  A validation system that only ever double-checks its own doubts can never catch its own blind spots</a:t>
+            </a:r>
+          </a:p>
+          <a:p>
+            <a:pPr>
+              <a:spcAft>
+                <a:spcPts val="1200"/>
+              </a:spcAft>
+            </a:pPr>
+            <a:r>
+              <a:rPr sz="2000" b="1">
+                <a:solidFill>
+                  <a:srgbClr val="1A1D27"/>
+                </a:solidFill>
+                <a:latin typeface="Calibri"/>
+              </a:rPr>
+              <a:t>▸  The audit sample is how you find out whether “zero flags” is actually trustworthy, or just confidently wrong</a:t>
+            </a:r>
+          </a:p>
+        </p:txBody>
+      </p:sp>
+      <p:sp>
+        <p:nvSpPr>
+          <p:cNvPr id="6" name="TextBox 5"/>
+          <p:cNvSpPr txBox="1"/>
+          <p:nvPr/>
+        </p:nvSpPr>
+        <p:spPr>
+          <a:xfrm>
+            <a:off x="11521440" y="6446520"/>
+            <a:ext cx="548640" cy="320040"/>
+          </a:xfrm>
+          <a:prstGeom prst="rect">
+            <a:avLst/>
+          </a:prstGeom>
+          <a:noFill/>
+        </p:spPr>
+        <p:txBody>
+          <a:bodyPr wrap="square">
+            <a:spAutoFit/>
+          </a:bodyPr>
+          <a:lstStyle/>
+          <a:p>
+            <a:pPr algn="r"/>
+            <a:r>
+              <a:rPr sz="1100" b="0" i="0">
                 <a:solidFill>
                   <a:srgbClr val="5B6374"/>
                 </a:solidFill>
                 <a:latin typeface="Calibri"/>
               </a:rPr>
-              <a:t>Module 2 of 3  ·  Data Processing → Analysis → Chunking</a:t>
+              <a:t>17</a:t>
+            </a:r>
+          </a:p>
+        </p:txBody>
+      </p:sp>
+    </p:spTree>
+  </p:cSld>
+  <p:clrMapOvr>
+    <a:masterClrMapping/>
+  </p:clrMapOvr>
+</p:sld>
+</file>
+
+<file path=ppt/slides/slide18.xml><?xml version="1.0" encoding="utf-8"?>
+<p:sld xmlns:a="http://schemas.openxmlformats.org/drawingml/2006/main" xmlns:p="http://schemas.openxmlformats.org/presentationml/2006/main" xmlns:r="http://schemas.openxmlformats.org/officeDocument/2006/relationships">
+  <p:cSld>
+    <p:bg>
+      <p:bgPr>
+        <a:solidFill>
+          <a:srgbClr val="FFFFFF"/>
+        </a:solidFill>
+        <a:effectLst/>
+      </p:bgPr>
+    </p:bg>
+    <p:spTree>
+      <p:nvGrpSpPr>
+        <p:cNvPr id="1" name=""/>
+        <p:cNvGrpSpPr/>
+        <p:nvPr/>
+      </p:nvGrpSpPr>
+      <p:grpSpPr/>
+      <p:sp>
+        <p:nvSpPr>
+          <p:cNvPr id="2" name="Rectangle 1"/>
+          <p:cNvSpPr/>
+          <p:nvPr/>
+        </p:nvSpPr>
+        <p:spPr>
+          <a:xfrm>
+            <a:off x="0" y="0"/>
+            <a:ext cx="12191695" cy="109728"/>
+          </a:xfrm>
+          <a:prstGeom prst="rect">
+            <a:avLst/>
+          </a:prstGeom>
+          <a:solidFill>
+            <a:srgbClr val="3E8EDE"/>
+          </a:solidFill>
+          <a:ln>
+            <a:noFill/>
+          </a:ln>
+        </p:spPr>
+        <p:style>
+          <a:lnRef idx="1">
+            <a:schemeClr val="accent1"/>
+          </a:lnRef>
+          <a:fillRef idx="3">
+            <a:schemeClr val="accent1"/>
+          </a:fillRef>
+          <a:effectRef idx="2">
+            <a:schemeClr val="accent1"/>
+          </a:effectRef>
+          <a:fontRef idx="minor">
+            <a:schemeClr val="lt1"/>
+          </a:fontRef>
+        </p:style>
+        <p:txBody>
+          <a:bodyPr rtlCol="0" anchor="ctr"/>
+          <a:lstStyle/>
+          <a:p>
+            <a:pPr algn="ctr"/>
+          </a:p>
+        </p:txBody>
+      </p:sp>
+      <p:sp>
+        <p:nvSpPr>
+          <p:cNvPr id="3" name="TextBox 2"/>
+          <p:cNvSpPr txBox="1"/>
+          <p:nvPr/>
+        </p:nvSpPr>
+        <p:spPr>
+          <a:xfrm>
+            <a:off x="640080" y="411480"/>
+            <a:ext cx="10881360" cy="457200"/>
+          </a:xfrm>
+          <a:prstGeom prst="rect">
+            <a:avLst/>
+          </a:prstGeom>
+          <a:noFill/>
+        </p:spPr>
+        <p:txBody>
+          <a:bodyPr wrap="square">
+            <a:spAutoFit/>
+          </a:bodyPr>
+          <a:lstStyle/>
+          <a:p>
+            <a:pPr algn="l"/>
+            <a:r>
+              <a:rPr sz="1500" b="1" i="0">
+                <a:solidFill>
+                  <a:srgbClr val="3E8EDE"/>
+                </a:solidFill>
+                <a:latin typeface="Calibri"/>
+              </a:rPr>
+              <a:t>PUTTING IT TOGETHER</a:t>
+            </a:r>
+          </a:p>
+        </p:txBody>
+      </p:sp>
+      <p:sp>
+        <p:nvSpPr>
+          <p:cNvPr id="4" name="TextBox 3"/>
+          <p:cNvSpPr txBox="1"/>
+          <p:nvPr/>
+        </p:nvSpPr>
+        <p:spPr>
+          <a:xfrm>
+            <a:off x="640080" y="777240"/>
+            <a:ext cx="10881360" cy="822960"/>
+          </a:xfrm>
+          <a:prstGeom prst="rect">
+            <a:avLst/>
+          </a:prstGeom>
+          <a:noFill/>
+        </p:spPr>
+        <p:txBody>
+          <a:bodyPr wrap="square">
+            <a:spAutoFit/>
+          </a:bodyPr>
+          <a:lstStyle/>
+          <a:p>
+            <a:pPr algn="l"/>
+            <a:r>
+              <a:rPr sz="3000" b="1" i="0">
+                <a:solidFill>
+                  <a:srgbClr val="1A1D27"/>
+                </a:solidFill>
+                <a:latin typeface="Calibri"/>
+              </a:rPr>
+              <a:t>A Simple Sampling Rule</a:t>
+            </a:r>
+          </a:p>
+        </p:txBody>
+      </p:sp>
+      <p:sp>
+        <p:nvSpPr>
+          <p:cNvPr id="5" name="TextBox 4"/>
+          <p:cNvSpPr txBox="1"/>
+          <p:nvPr/>
+        </p:nvSpPr>
+        <p:spPr>
+          <a:xfrm>
+            <a:off x="731520" y="1691640"/>
+            <a:ext cx="10698480" cy="4480560"/>
+          </a:xfrm>
+          <a:prstGeom prst="rect">
+            <a:avLst/>
+          </a:prstGeom>
+          <a:noFill/>
+        </p:spPr>
+        <p:txBody>
+          <a:bodyPr wrap="square">
+            <a:spAutoFit/>
+          </a:bodyPr>
+          <a:lstStyle/>
+          <a:p>
+            <a:pPr>
+              <a:spcAft>
+                <a:spcPts val="1200"/>
+              </a:spcAft>
+            </a:pPr>
+            <a:r>
+              <a:rPr sz="2000" b="1">
+                <a:solidFill>
+                  <a:srgbClr val="1A1D27"/>
+                </a:solidFill>
+                <a:latin typeface="Calibri"/>
+              </a:rPr>
+              <a:t>▸  Review: 100% of flagged documents, plus a random 5-10% audit of the clean bucket, plus any tokens/page outlier (previous slide) -- flagged or not</a:t>
+            </a:r>
+          </a:p>
+          <a:p>
+            <a:pPr>
+              <a:spcAft>
+                <a:spcPts val="1200"/>
+              </a:spcAft>
+            </a:pPr>
+            <a:r>
+              <a:rPr sz="2000" b="1">
+                <a:solidFill>
+                  <a:srgbClr val="1A1D27"/>
+                </a:solidFill>
+                <a:latin typeface="Calibri"/>
+              </a:rPr>
+              <a:t>▸  If the audit sample starts turning up real problems, raise the audit percentage -- the hit rate tells you whether 5-10% is actually enough</a:t>
+            </a:r>
+          </a:p>
+          <a:p>
+            <a:pPr>
+              <a:spcAft>
+                <a:spcPts val="600"/>
+              </a:spcAft>
+            </a:pPr>
+            <a:r>
+              <a:rPr sz="1600" b="0">
+                <a:solidFill>
+                  <a:srgbClr val="5B6374"/>
+                </a:solidFill>
+                <a:latin typeface="Calibri"/>
+              </a:rPr>
+              <a:t>     –  e.g., audits at 5% keep finding real issues → raise to 10-15% and re-check until it mostly comes back clean</a:t>
+            </a:r>
+          </a:p>
+        </p:txBody>
+      </p:sp>
+      <p:sp>
+        <p:nvSpPr>
+          <p:cNvPr id="6" name="TextBox 5"/>
+          <p:cNvSpPr txBox="1"/>
+          <p:nvPr/>
+        </p:nvSpPr>
+        <p:spPr>
+          <a:xfrm>
+            <a:off x="731520" y="6263640"/>
+            <a:ext cx="10698480" cy="411480"/>
+          </a:xfrm>
+          <a:prstGeom prst="rect">
+            <a:avLst/>
+          </a:prstGeom>
+          <a:noFill/>
+        </p:spPr>
+        <p:txBody>
+          <a:bodyPr wrap="square">
+            <a:spAutoFit/>
+          </a:bodyPr>
+          <a:lstStyle/>
+          <a:p>
+            <a:pPr algn="l"/>
+            <a:r>
+              <a:rPr sz="1200" b="0" i="1">
+                <a:solidFill>
+                  <a:srgbClr val="5B6374"/>
+                </a:solidFill>
+                <a:latin typeface="Calibri"/>
+              </a:rPr>
+              <a:t>This is methodology, not a result -- honest about what a 3-document teaching corpus can and can't demonstrate. The same low_confidence_count / dropped_region_count / tokens_per_page columns already in the Excel report are exactly what a sampling rule would key off of at real scale.</a:t>
+            </a:r>
+          </a:p>
+        </p:txBody>
+      </p:sp>
+      <p:sp>
+        <p:nvSpPr>
+          <p:cNvPr id="7" name="TextBox 6"/>
+          <p:cNvSpPr txBox="1"/>
+          <p:nvPr/>
+        </p:nvSpPr>
+        <p:spPr>
+          <a:xfrm>
+            <a:off x="11521440" y="6446520"/>
+            <a:ext cx="548640" cy="320040"/>
+          </a:xfrm>
+          <a:prstGeom prst="rect">
+            <a:avLst/>
+          </a:prstGeom>
+          <a:noFill/>
+        </p:spPr>
+        <p:txBody>
+          <a:bodyPr wrap="square">
+            <a:spAutoFit/>
+          </a:bodyPr>
+          <a:lstStyle/>
+          <a:p>
+            <a:pPr algn="r"/>
+            <a:r>
+              <a:rPr sz="1100" b="0" i="0">
+                <a:solidFill>
+                  <a:srgbClr val="5B6374"/>
+                </a:solidFill>
+                <a:latin typeface="Calibri"/>
+              </a:rPr>
+              <a:t>18</a:t>
+            </a:r>
+          </a:p>
+        </p:txBody>
+      </p:sp>
+    </p:spTree>
+  </p:cSld>
+  <p:clrMapOvr>
+    <a:masterClrMapping/>
+  </p:clrMapOvr>
+</p:sld>
+</file>
+
+<file path=ppt/slides/slide19.xml><?xml version="1.0" encoding="utf-8"?>
+<p:sld xmlns:a="http://schemas.openxmlformats.org/drawingml/2006/main" xmlns:p="http://schemas.openxmlformats.org/presentationml/2006/main" xmlns:r="http://schemas.openxmlformats.org/officeDocument/2006/relationships">
+  <p:cSld>
+    <p:bg>
+      <p:bgPr>
+        <a:solidFill>
+          <a:srgbClr val="FFFFFF"/>
+        </a:solidFill>
+        <a:effectLst/>
+      </p:bgPr>
+    </p:bg>
+    <p:spTree>
+      <p:nvGrpSpPr>
+        <p:cNvPr id="1" name=""/>
+        <p:cNvGrpSpPr/>
+        <p:nvPr/>
+      </p:nvGrpSpPr>
+      <p:grpSpPr/>
+      <p:sp>
+        <p:nvSpPr>
+          <p:cNvPr id="2" name="Rectangle 1"/>
+          <p:cNvSpPr/>
+          <p:nvPr/>
+        </p:nvSpPr>
+        <p:spPr>
+          <a:xfrm>
+            <a:off x="0" y="0"/>
+            <a:ext cx="12191695" cy="109728"/>
+          </a:xfrm>
+          <a:prstGeom prst="rect">
+            <a:avLst/>
+          </a:prstGeom>
+          <a:solidFill>
+            <a:srgbClr val="3E8EDE"/>
+          </a:solidFill>
+          <a:ln>
+            <a:noFill/>
+          </a:ln>
+        </p:spPr>
+        <p:style>
+          <a:lnRef idx="1">
+            <a:schemeClr val="accent1"/>
+          </a:lnRef>
+          <a:fillRef idx="3">
+            <a:schemeClr val="accent1"/>
+          </a:fillRef>
+          <a:effectRef idx="2">
+            <a:schemeClr val="accent1"/>
+          </a:effectRef>
+          <a:fontRef idx="minor">
+            <a:schemeClr val="lt1"/>
+          </a:fontRef>
+        </p:style>
+        <p:txBody>
+          <a:bodyPr rtlCol="0" anchor="ctr"/>
+          <a:lstStyle/>
+          <a:p>
+            <a:pPr algn="ctr"/>
+          </a:p>
+        </p:txBody>
+      </p:sp>
+      <p:sp>
+        <p:nvSpPr>
+          <p:cNvPr id="3" name="TextBox 2"/>
+          <p:cNvSpPr txBox="1"/>
+          <p:nvPr/>
+        </p:nvSpPr>
+        <p:spPr>
+          <a:xfrm>
+            <a:off x="640080" y="411480"/>
+            <a:ext cx="10881360" cy="457200"/>
+          </a:xfrm>
+          <a:prstGeom prst="rect">
+            <a:avLst/>
+          </a:prstGeom>
+          <a:noFill/>
+        </p:spPr>
+        <p:txBody>
+          <a:bodyPr wrap="square">
+            <a:spAutoFit/>
+          </a:bodyPr>
+          <a:lstStyle/>
+          <a:p>
+            <a:pPr algn="l"/>
+            <a:r>
+              <a:rPr sz="1500" b="1" i="0">
+                <a:solidFill>
+                  <a:srgbClr val="3E8EDE"/>
+                </a:solidFill>
+                <a:latin typeface="Calibri"/>
+              </a:rPr>
+              <a:t>A QUIET DETAIL</a:t>
+            </a:r>
+          </a:p>
+        </p:txBody>
+      </p:sp>
+      <p:sp>
+        <p:nvSpPr>
+          <p:cNvPr id="4" name="TextBox 3"/>
+          <p:cNvSpPr txBox="1"/>
+          <p:nvPr/>
+        </p:nvSpPr>
+        <p:spPr>
+          <a:xfrm>
+            <a:off x="640080" y="777240"/>
+            <a:ext cx="10881360" cy="822960"/>
+          </a:xfrm>
+          <a:prstGeom prst="rect">
+            <a:avLst/>
+          </a:prstGeom>
+          <a:noFill/>
+        </p:spPr>
+        <p:txBody>
+          <a:bodyPr wrap="square">
+            <a:spAutoFit/>
+          </a:bodyPr>
+          <a:lstStyle/>
+          <a:p>
+            <a:pPr algn="l"/>
+            <a:r>
+              <a:rPr sz="3000" b="1" i="0">
+                <a:solidFill>
+                  <a:srgbClr val="1A1D27"/>
+                </a:solidFill>
+                <a:latin typeface="Calibri"/>
+              </a:rPr>
+              <a:t>Partial Runs Get Skipped, Not Guessed At</a:t>
+            </a:r>
+          </a:p>
+        </p:txBody>
+      </p:sp>
+      <p:sp>
+        <p:nvSpPr>
+          <p:cNvPr id="5" name="TextBox 4"/>
+          <p:cNvSpPr txBox="1"/>
+          <p:nvPr/>
+        </p:nvSpPr>
+        <p:spPr>
+          <a:xfrm>
+            <a:off x="731520" y="1691640"/>
+            <a:ext cx="10698480" cy="4480560"/>
+          </a:xfrm>
+          <a:prstGeom prst="rect">
+            <a:avLst/>
+          </a:prstGeom>
+          <a:noFill/>
+        </p:spPr>
+        <p:txBody>
+          <a:bodyPr wrap="square">
+            <a:spAutoFit/>
+          </a:bodyPr>
+          <a:lstStyle/>
+          <a:p>
+            <a:pPr>
+              <a:spcAft>
+                <a:spcPts val="1200"/>
+              </a:spcAft>
+            </a:pPr>
+            <a:r>
+              <a:rPr sz="2000" b="1">
+                <a:solidFill>
+                  <a:srgbClr val="1A1D27"/>
+                </a:solidFill>
+                <a:latin typeface="Calibri"/>
+              </a:rPr>
+              <a:t>▸  A document only gets analyzed once its extraction has actually finished, not while it's still in progress</a:t>
+            </a:r>
+          </a:p>
+          <a:p>
+            <a:pPr>
+              <a:spcAft>
+                <a:spcPts val="1200"/>
+              </a:spcAft>
+            </a:pPr>
+            <a:r>
+              <a:rPr sz="2000" b="1">
+                <a:solidFill>
+                  <a:srgbClr val="1A1D27"/>
+                </a:solidFill>
+                <a:latin typeface="Calibri"/>
+              </a:rPr>
+              <a:t>▸  An interrupted or still-running extraction leaves incomplete output</a:t>
+            </a:r>
+          </a:p>
+          <a:p>
+            <a:pPr>
+              <a:spcAft>
+                <a:spcPts val="1200"/>
+              </a:spcAft>
+            </a:pPr>
+            <a:r>
+              <a:rPr sz="2000" b="1">
+                <a:solidFill>
+                  <a:srgbClr val="1A1D27"/>
+                </a:solidFill>
+                <a:latin typeface="Calibri"/>
+              </a:rPr>
+              <a:t>▸  That incomplete output gets skipped rather than guessed at -- a document either finished cleanly, or it isn't validated at all</a:t>
+            </a:r>
+          </a:p>
+        </p:txBody>
+      </p:sp>
+      <p:sp>
+        <p:nvSpPr>
+          <p:cNvPr id="6" name="TextBox 5"/>
+          <p:cNvSpPr txBox="1"/>
+          <p:nvPr/>
+        </p:nvSpPr>
+        <p:spPr>
+          <a:xfrm>
+            <a:off x="11521440" y="6446520"/>
+            <a:ext cx="548640" cy="320040"/>
+          </a:xfrm>
+          <a:prstGeom prst="rect">
+            <a:avLst/>
+          </a:prstGeom>
+          <a:noFill/>
+        </p:spPr>
+        <p:txBody>
+          <a:bodyPr wrap="square">
+            <a:spAutoFit/>
+          </a:bodyPr>
+          <a:lstStyle/>
+          <a:p>
+            <a:pPr algn="r"/>
+            <a:r>
+              <a:rPr sz="1100" b="0" i="0">
+                <a:solidFill>
+                  <a:srgbClr val="5B6374"/>
+                </a:solidFill>
+                <a:latin typeface="Calibri"/>
+              </a:rPr>
+              <a:t>19</a:t>
             </a:r>
           </a:p>
         </p:txBody>
@@ -5503,6 +6314,457 @@
 </p:sld>
 </file>
 
+<file path=ppt/slides/slide20.xml><?xml version="1.0" encoding="utf-8"?>
+<p:sld xmlns:a="http://schemas.openxmlformats.org/drawingml/2006/main" xmlns:p="http://schemas.openxmlformats.org/presentationml/2006/main" xmlns:r="http://schemas.openxmlformats.org/officeDocument/2006/relationships">
+  <p:cSld>
+    <p:bg>
+      <p:bgPr>
+        <a:solidFill>
+          <a:srgbClr val="FFFFFF"/>
+        </a:solidFill>
+        <a:effectLst/>
+      </p:bgPr>
+    </p:bg>
+    <p:spTree>
+      <p:nvGrpSpPr>
+        <p:cNvPr id="1" name=""/>
+        <p:cNvGrpSpPr/>
+        <p:nvPr/>
+      </p:nvGrpSpPr>
+      <p:grpSpPr/>
+      <p:sp>
+        <p:nvSpPr>
+          <p:cNvPr id="2" name="Rectangle 1"/>
+          <p:cNvSpPr/>
+          <p:nvPr/>
+        </p:nvSpPr>
+        <p:spPr>
+          <a:xfrm>
+            <a:off x="0" y="0"/>
+            <a:ext cx="12191695" cy="109728"/>
+          </a:xfrm>
+          <a:prstGeom prst="rect">
+            <a:avLst/>
+          </a:prstGeom>
+          <a:solidFill>
+            <a:srgbClr val="3E8EDE"/>
+          </a:solidFill>
+          <a:ln>
+            <a:noFill/>
+          </a:ln>
+        </p:spPr>
+        <p:style>
+          <a:lnRef idx="1">
+            <a:schemeClr val="accent1"/>
+          </a:lnRef>
+          <a:fillRef idx="3">
+            <a:schemeClr val="accent1"/>
+          </a:fillRef>
+          <a:effectRef idx="2">
+            <a:schemeClr val="accent1"/>
+          </a:effectRef>
+          <a:fontRef idx="minor">
+            <a:schemeClr val="lt1"/>
+          </a:fontRef>
+        </p:style>
+        <p:txBody>
+          <a:bodyPr rtlCol="0" anchor="ctr"/>
+          <a:lstStyle/>
+          <a:p>
+            <a:pPr algn="ctr"/>
+          </a:p>
+        </p:txBody>
+      </p:sp>
+      <p:sp>
+        <p:nvSpPr>
+          <p:cNvPr id="3" name="TextBox 2"/>
+          <p:cNvSpPr txBox="1"/>
+          <p:nvPr/>
+        </p:nvSpPr>
+        <p:spPr>
+          <a:xfrm>
+            <a:off x="640080" y="411480"/>
+            <a:ext cx="10881360" cy="457200"/>
+          </a:xfrm>
+          <a:prstGeom prst="rect">
+            <a:avLst/>
+          </a:prstGeom>
+          <a:noFill/>
+        </p:spPr>
+        <p:txBody>
+          <a:bodyPr wrap="square">
+            <a:spAutoFit/>
+          </a:bodyPr>
+          <a:lstStyle/>
+          <a:p>
+            <a:pPr algn="l"/>
+            <a:r>
+              <a:rPr sz="1500" b="1" i="0">
+                <a:solidFill>
+                  <a:srgbClr val="3E8EDE"/>
+                </a:solidFill>
+                <a:latin typeface="Calibri"/>
+              </a:rPr>
+              <a:t>WRAP-UP</a:t>
+            </a:r>
+          </a:p>
+        </p:txBody>
+      </p:sp>
+      <p:sp>
+        <p:nvSpPr>
+          <p:cNvPr id="4" name="TextBox 3"/>
+          <p:cNvSpPr txBox="1"/>
+          <p:nvPr/>
+        </p:nvSpPr>
+        <p:spPr>
+          <a:xfrm>
+            <a:off x="640080" y="777240"/>
+            <a:ext cx="10881360" cy="822960"/>
+          </a:xfrm>
+          <a:prstGeom prst="rect">
+            <a:avLst/>
+          </a:prstGeom>
+          <a:noFill/>
+        </p:spPr>
+        <p:txBody>
+          <a:bodyPr wrap="square">
+            <a:spAutoFit/>
+          </a:bodyPr>
+          <a:lstStyle/>
+          <a:p>
+            <a:pPr algn="l"/>
+            <a:r>
+              <a:rPr sz="3000" b="1" i="0">
+                <a:solidFill>
+                  <a:srgbClr val="1A1D27"/>
+                </a:solidFill>
+                <a:latin typeface="Calibri"/>
+              </a:rPr>
+              <a:t>Why This Module Matters</a:t>
+            </a:r>
+          </a:p>
+        </p:txBody>
+      </p:sp>
+      <p:sp>
+        <p:nvSpPr>
+          <p:cNvPr id="5" name="TextBox 4"/>
+          <p:cNvSpPr txBox="1"/>
+          <p:nvPr/>
+        </p:nvSpPr>
+        <p:spPr>
+          <a:xfrm>
+            <a:off x="731520" y="1691640"/>
+            <a:ext cx="10698480" cy="4480560"/>
+          </a:xfrm>
+          <a:prstGeom prst="rect">
+            <a:avLst/>
+          </a:prstGeom>
+          <a:noFill/>
+        </p:spPr>
+        <p:txBody>
+          <a:bodyPr wrap="square">
+            <a:spAutoFit/>
+          </a:bodyPr>
+          <a:lstStyle/>
+          <a:p>
+            <a:pPr>
+              <a:spcAft>
+                <a:spcPts val="1000"/>
+              </a:spcAft>
+            </a:pPr>
+            <a:r>
+              <a:rPr sz="1800" b="1">
+                <a:solidFill>
+                  <a:srgbClr val="1A1D27"/>
+                </a:solidFill>
+                <a:latin typeface="Calibri"/>
+              </a:rPr>
+              <a:t>▸  It turns “the pipeline didn't crash” into “here's proof this document is actually usable”</a:t>
+            </a:r>
+          </a:p>
+          <a:p>
+            <a:pPr>
+              <a:spcAft>
+                <a:spcPts val="1000"/>
+              </a:spcAft>
+            </a:pPr>
+            <a:r>
+              <a:rPr sz="1800" b="1">
+                <a:solidFill>
+                  <a:srgbClr val="1A1D27"/>
+                </a:solidFill>
+                <a:latin typeface="Calibri"/>
+              </a:rPr>
+              <a:t>▸  Two independent checks, not one -- token analysis for how much came out, layout analysis for whether the model saw the page correctly</a:t>
+            </a:r>
+          </a:p>
+          <a:p>
+            <a:pPr>
+              <a:spcAft>
+                <a:spcPts val="1000"/>
+              </a:spcAft>
+            </a:pPr>
+            <a:r>
+              <a:rPr sz="1800" b="1">
+                <a:solidFill>
+                  <a:srgbClr val="1A1D27"/>
+                </a:solidFill>
+                <a:latin typeface="Calibri"/>
+              </a:rPr>
+              <a:t>▸  It's human-in-the-loop by design -- every flag carries an exact way back to the page a person needs to look at</a:t>
+            </a:r>
+          </a:p>
+          <a:p>
+            <a:pPr>
+              <a:spcAft>
+                <a:spcPts val="1000"/>
+              </a:spcAft>
+            </a:pPr>
+            <a:r>
+              <a:rPr sz="1800" b="1">
+                <a:solidFill>
+                  <a:srgbClr val="1A1D27"/>
+                </a:solidFill>
+                <a:latin typeface="Calibri"/>
+              </a:rPr>
+              <a:t>▸  It scales past hand-checking every document -- targeted review of what's flagged, random audits of what isn't, once the corpus is bigger than 3 files</a:t>
+            </a:r>
+          </a:p>
+          <a:p>
+            <a:pPr>
+              <a:spcAft>
+                <a:spcPts val="1000"/>
+              </a:spcAft>
+            </a:pPr>
+            <a:r>
+              <a:rPr sz="1800" b="1">
+                <a:solidFill>
+                  <a:srgbClr val="1A1D27"/>
+                </a:solidFill>
+                <a:latin typeface="Calibri"/>
+              </a:rPr>
+              <a:t>▸  Next: Module 3 takes this same validated output and turns it into retrieval-ready chunks -- recursive, semantic, and hierarchical strategies, compared on the same real documents</a:t>
+            </a:r>
+          </a:p>
+        </p:txBody>
+      </p:sp>
+      <p:sp>
+        <p:nvSpPr>
+          <p:cNvPr id="6" name="TextBox 5"/>
+          <p:cNvSpPr txBox="1"/>
+          <p:nvPr/>
+        </p:nvSpPr>
+        <p:spPr>
+          <a:xfrm>
+            <a:off x="11521440" y="6446520"/>
+            <a:ext cx="548640" cy="320040"/>
+          </a:xfrm>
+          <a:prstGeom prst="rect">
+            <a:avLst/>
+          </a:prstGeom>
+          <a:noFill/>
+        </p:spPr>
+        <p:txBody>
+          <a:bodyPr wrap="square">
+            <a:spAutoFit/>
+          </a:bodyPr>
+          <a:lstStyle/>
+          <a:p>
+            <a:pPr algn="r"/>
+            <a:r>
+              <a:rPr sz="1100" b="0" i="0">
+                <a:solidFill>
+                  <a:srgbClr val="5B6374"/>
+                </a:solidFill>
+                <a:latin typeface="Calibri"/>
+              </a:rPr>
+              <a:t>20</a:t>
+            </a:r>
+          </a:p>
+        </p:txBody>
+      </p:sp>
+    </p:spTree>
+  </p:cSld>
+  <p:clrMapOvr>
+    <a:masterClrMapping/>
+  </p:clrMapOvr>
+</p:sld>
+</file>
+
+<file path=ppt/slides/slide21.xml><?xml version="1.0" encoding="utf-8"?>
+<p:sld xmlns:a="http://schemas.openxmlformats.org/drawingml/2006/main" xmlns:p="http://schemas.openxmlformats.org/presentationml/2006/main" xmlns:r="http://schemas.openxmlformats.org/officeDocument/2006/relationships">
+  <p:cSld>
+    <p:bg>
+      <p:bgPr>
+        <a:solidFill>
+          <a:srgbClr val="0F172A"/>
+        </a:solidFill>
+        <a:effectLst/>
+      </p:bgPr>
+    </p:bg>
+    <p:spTree>
+      <p:nvGrpSpPr>
+        <p:cNvPr id="1" name=""/>
+        <p:cNvGrpSpPr/>
+        <p:nvPr/>
+      </p:nvGrpSpPr>
+      <p:grpSpPr/>
+      <p:sp>
+        <p:nvSpPr>
+          <p:cNvPr id="2" name="Rectangle 1"/>
+          <p:cNvSpPr/>
+          <p:nvPr/>
+        </p:nvSpPr>
+        <p:spPr>
+          <a:xfrm>
+            <a:off x="0" y="0"/>
+            <a:ext cx="12191695" cy="109728"/>
+          </a:xfrm>
+          <a:prstGeom prst="rect">
+            <a:avLst/>
+          </a:prstGeom>
+          <a:solidFill>
+            <a:srgbClr val="3E8EDE"/>
+          </a:solidFill>
+          <a:ln>
+            <a:noFill/>
+          </a:ln>
+        </p:spPr>
+        <p:style>
+          <a:lnRef idx="1">
+            <a:schemeClr val="accent1"/>
+          </a:lnRef>
+          <a:fillRef idx="3">
+            <a:schemeClr val="accent1"/>
+          </a:fillRef>
+          <a:effectRef idx="2">
+            <a:schemeClr val="accent1"/>
+          </a:effectRef>
+          <a:fontRef idx="minor">
+            <a:schemeClr val="lt1"/>
+          </a:fontRef>
+        </p:style>
+        <p:txBody>
+          <a:bodyPr rtlCol="0" anchor="ctr"/>
+          <a:lstStyle/>
+          <a:p>
+            <a:pPr algn="ctr"/>
+          </a:p>
+        </p:txBody>
+      </p:sp>
+      <p:sp>
+        <p:nvSpPr>
+          <p:cNvPr id="3" name="TextBox 2"/>
+          <p:cNvSpPr txBox="1"/>
+          <p:nvPr/>
+        </p:nvSpPr>
+        <p:spPr>
+          <a:xfrm>
+            <a:off x="914400" y="2743200"/>
+            <a:ext cx="10332720" cy="1097280"/>
+          </a:xfrm>
+          <a:prstGeom prst="rect">
+            <a:avLst/>
+          </a:prstGeom>
+          <a:noFill/>
+        </p:spPr>
+        <p:txBody>
+          <a:bodyPr wrap="square">
+            <a:spAutoFit/>
+          </a:bodyPr>
+          <a:lstStyle/>
+          <a:p>
+            <a:pPr algn="l"/>
+            <a:r>
+              <a:rPr sz="4000" b="1" i="0">
+                <a:solidFill>
+                  <a:srgbClr val="FFFFFF"/>
+                </a:solidFill>
+                <a:latin typeface="Calibri"/>
+              </a:rPr>
+              <a:t>Questions?</a:t>
+            </a:r>
+          </a:p>
+        </p:txBody>
+      </p:sp>
+      <p:sp>
+        <p:nvSpPr>
+          <p:cNvPr id="4" name="TextBox 3"/>
+          <p:cNvSpPr txBox="1"/>
+          <p:nvPr/>
+        </p:nvSpPr>
+        <p:spPr>
+          <a:xfrm>
+            <a:off x="914400" y="3749039"/>
+            <a:ext cx="10332720" cy="1280160"/>
+          </a:xfrm>
+          <a:prstGeom prst="rect">
+            <a:avLst/>
+          </a:prstGeom>
+          <a:noFill/>
+        </p:spPr>
+        <p:txBody>
+          <a:bodyPr wrap="square">
+            <a:spAutoFit/>
+          </a:bodyPr>
+          <a:lstStyle/>
+          <a:p>
+            <a:pPr algn="l"/>
+            <a:r>
+              <a:rPr sz="1800" b="0" i="0">
+                <a:solidFill>
+                  <a:srgbClr val="8A93A6"/>
+                </a:solidFill>
+                <a:latin typeface="Calibri"/>
+              </a:rPr>
+              <a:t>2. ANALYSIS/  --  README.md has the full column-by-column report reference and every real number in this deck.</a:t>
+            </a:r>
+          </a:p>
+        </p:txBody>
+      </p:sp>
+      <p:sp>
+        <p:nvSpPr>
+          <p:cNvPr id="5" name="TextBox 4"/>
+          <p:cNvSpPr txBox="1"/>
+          <p:nvPr/>
+        </p:nvSpPr>
+        <p:spPr>
+          <a:xfrm>
+            <a:off x="914400" y="6126480"/>
+            <a:ext cx="10332720" cy="457200"/>
+          </a:xfrm>
+          <a:prstGeom prst="rect">
+            <a:avLst/>
+          </a:prstGeom>
+          <a:noFill/>
+        </p:spPr>
+        <p:txBody>
+          <a:bodyPr wrap="square">
+            <a:spAutoFit/>
+          </a:bodyPr>
+          <a:lstStyle/>
+          <a:p>
+            <a:pPr algn="l"/>
+            <a:r>
+              <a:rPr sz="1300" b="0" i="0">
+                <a:solidFill>
+                  <a:srgbClr val="5B6374"/>
+                </a:solidFill>
+                <a:latin typeface="Calibri"/>
+              </a:rPr>
+              <a:t>Module 2 of 3  ·  Data Processing → Analysis → Chunking</a:t>
+            </a:r>
+          </a:p>
+        </p:txBody>
+      </p:sp>
+    </p:spTree>
+  </p:cSld>
+  <p:clrMapOvr>
+    <a:masterClrMapping/>
+  </p:clrMapOvr>
+</p:sld>
+</file>
+
 <file path=ppt/slides/slide3.xml><?xml version="1.0" encoding="utf-8"?>
 <p:sld xmlns:a="http://schemas.openxmlformats.org/drawingml/2006/main" xmlns:p="http://schemas.openxmlformats.org/presentationml/2006/main" xmlns:r="http://schemas.openxmlformats.org/officeDocument/2006/relationships">
   <p:cSld>
@@ -6377,7 +7639,7 @@
                 </a:solidFill>
                 <a:latin typeface="Calibri"/>
               </a:rPr>
-              <a:t>THE CORE QUESTION</a:t>
+              <a:t>WORDS VS. TOKENS</a:t>
             </a:r>
           </a:p>
         </p:txBody>
@@ -6412,7 +7674,7 @@
                 </a:solidFill>
                 <a:latin typeface="Calibri"/>
               </a:rPr>
-              <a:t>How Many Tokens Per Page, Really?</a:t>
+              <a:t>Why “Word Count” Isn't Enough</a:t>
             </a:r>
           </a:p>
         </p:txBody>
@@ -6451,7 +7713,7 @@
                 </a:solidFill>
                 <a:latin typeface="Calibri"/>
               </a:rPr>
-              <a:t>▸  “Word count” is not “token count.” A word can be one token, several tokens, or a fraction of a shared token -- it depends on the tokenizer</a:t>
+              <a:t>▸  A word can be one token, several tokens, or a fraction of a token shared with other words -- it depends entirely on the tokenizer</a:t>
             </a:r>
           </a:p>
           <a:p>
@@ -6467,7 +7729,7 @@
                 </a:solidFill>
                 <a:latin typeface="Calibri"/>
               </a:rPr>
-              <a:t>▸  Why this matters here specifically: every downstream step (chunking, any embedding or LLM call) is budgeted in tokens, not words or characters</a:t>
+              <a:t>▸  So two documents with the same word count can have very different token counts, and vice versa</a:t>
             </a:r>
           </a:p>
           <a:p>
@@ -6483,7 +7745,7 @@
                 </a:solidFill>
                 <a:latin typeface="Calibri"/>
               </a:rPr>
-              <a:t>▸  So this module counts tokens with the SAME tokenizer the extraction model uses, rather than estimating -- an approximation here would quietly mislead every step after it</a:t>
+              <a:t>▸  Word count is a rough proxy at best. If token count is what actually matters downstream, word count isn't a stand-in for it</a:t>
             </a:r>
           </a:p>
         </p:txBody>
@@ -6532,6 +7794,496 @@
 </file>
 
 <file path=ppt/slides/slide7.xml><?xml version="1.0" encoding="utf-8"?>
+<p:sld xmlns:a="http://schemas.openxmlformats.org/drawingml/2006/main" xmlns:p="http://schemas.openxmlformats.org/presentationml/2006/main" xmlns:r="http://schemas.openxmlformats.org/officeDocument/2006/relationships">
+  <p:cSld>
+    <p:bg>
+      <p:bgPr>
+        <a:solidFill>
+          <a:srgbClr val="FFFFFF"/>
+        </a:solidFill>
+        <a:effectLst/>
+      </p:bgPr>
+    </p:bg>
+    <p:spTree>
+      <p:nvGrpSpPr>
+        <p:cNvPr id="1" name=""/>
+        <p:cNvGrpSpPr/>
+        <p:nvPr/>
+      </p:nvGrpSpPr>
+      <p:grpSpPr/>
+      <p:sp>
+        <p:nvSpPr>
+          <p:cNvPr id="2" name="Rectangle 1"/>
+          <p:cNvSpPr/>
+          <p:nvPr/>
+        </p:nvSpPr>
+        <p:spPr>
+          <a:xfrm>
+            <a:off x="0" y="0"/>
+            <a:ext cx="12191695" cy="109728"/>
+          </a:xfrm>
+          <a:prstGeom prst="rect">
+            <a:avLst/>
+          </a:prstGeom>
+          <a:solidFill>
+            <a:srgbClr val="3E8EDE"/>
+          </a:solidFill>
+          <a:ln>
+            <a:noFill/>
+          </a:ln>
+        </p:spPr>
+        <p:style>
+          <a:lnRef idx="1">
+            <a:schemeClr val="accent1"/>
+          </a:lnRef>
+          <a:fillRef idx="3">
+            <a:schemeClr val="accent1"/>
+          </a:fillRef>
+          <a:effectRef idx="2">
+            <a:schemeClr val="accent1"/>
+          </a:effectRef>
+          <a:fontRef idx="minor">
+            <a:schemeClr val="lt1"/>
+          </a:fontRef>
+        </p:style>
+        <p:txBody>
+          <a:bodyPr rtlCol="0" anchor="ctr"/>
+          <a:lstStyle/>
+          <a:p>
+            <a:pPr algn="ctr"/>
+          </a:p>
+        </p:txBody>
+      </p:sp>
+      <p:sp>
+        <p:nvSpPr>
+          <p:cNvPr id="3" name="TextBox 2"/>
+          <p:cNvSpPr txBox="1"/>
+          <p:nvPr/>
+        </p:nvSpPr>
+        <p:spPr>
+          <a:xfrm>
+            <a:off x="640080" y="411480"/>
+            <a:ext cx="10881360" cy="457200"/>
+          </a:xfrm>
+          <a:prstGeom prst="rect">
+            <a:avLst/>
+          </a:prstGeom>
+          <a:noFill/>
+        </p:spPr>
+        <p:txBody>
+          <a:bodyPr wrap="square">
+            <a:spAutoFit/>
+          </a:bodyPr>
+          <a:lstStyle/>
+          <a:p>
+            <a:pPr algn="l"/>
+            <a:r>
+              <a:rPr sz="1500" b="1" i="0">
+                <a:solidFill>
+                  <a:srgbClr val="3E8EDE"/>
+                </a:solidFill>
+                <a:latin typeface="Calibri"/>
+              </a:rPr>
+              <a:t>WHY IT MATTERS HERE</a:t>
+            </a:r>
+          </a:p>
+        </p:txBody>
+      </p:sp>
+      <p:sp>
+        <p:nvSpPr>
+          <p:cNvPr id="4" name="TextBox 3"/>
+          <p:cNvSpPr txBox="1"/>
+          <p:nvPr/>
+        </p:nvSpPr>
+        <p:spPr>
+          <a:xfrm>
+            <a:off x="640080" y="777240"/>
+            <a:ext cx="10881360" cy="822960"/>
+          </a:xfrm>
+          <a:prstGeom prst="rect">
+            <a:avLst/>
+          </a:prstGeom>
+          <a:noFill/>
+        </p:spPr>
+        <p:txBody>
+          <a:bodyPr wrap="square">
+            <a:spAutoFit/>
+          </a:bodyPr>
+          <a:lstStyle/>
+          <a:p>
+            <a:pPr algn="l"/>
+            <a:r>
+              <a:rPr sz="3000" b="1" i="0">
+                <a:solidFill>
+                  <a:srgbClr val="1A1D27"/>
+                </a:solidFill>
+                <a:latin typeface="Calibri"/>
+              </a:rPr>
+              <a:t>Every Downstream Step Is Budgeted in Tokens</a:t>
+            </a:r>
+          </a:p>
+        </p:txBody>
+      </p:sp>
+      <p:sp>
+        <p:nvSpPr>
+          <p:cNvPr id="5" name="TextBox 4"/>
+          <p:cNvSpPr txBox="1"/>
+          <p:nvPr/>
+        </p:nvSpPr>
+        <p:spPr>
+          <a:xfrm>
+            <a:off x="731520" y="1691640"/>
+            <a:ext cx="10698480" cy="4480560"/>
+          </a:xfrm>
+          <a:prstGeom prst="rect">
+            <a:avLst/>
+          </a:prstGeom>
+          <a:noFill/>
+        </p:spPr>
+        <p:txBody>
+          <a:bodyPr wrap="square">
+            <a:spAutoFit/>
+          </a:bodyPr>
+          <a:lstStyle/>
+          <a:p>
+            <a:pPr>
+              <a:spcAft>
+                <a:spcPts val="1200"/>
+              </a:spcAft>
+            </a:pPr>
+            <a:r>
+              <a:rPr sz="2000" b="1">
+                <a:solidFill>
+                  <a:srgbClr val="1A1D27"/>
+                </a:solidFill>
+                <a:latin typeface="Calibri"/>
+              </a:rPr>
+              <a:t>▸  Chunking (Module 3) splits documents by token count, not word count or character count</a:t>
+            </a:r>
+          </a:p>
+          <a:p>
+            <a:pPr>
+              <a:spcAft>
+                <a:spcPts val="1200"/>
+              </a:spcAft>
+            </a:pPr>
+            <a:r>
+              <a:rPr sz="2000" b="1">
+                <a:solidFill>
+                  <a:srgbClr val="1A1D27"/>
+                </a:solidFill>
+                <a:latin typeface="Calibri"/>
+              </a:rPr>
+              <a:t>▸  Every embedding call and every LLM call downstream has a token limit, not a word limit</a:t>
+            </a:r>
+          </a:p>
+          <a:p>
+            <a:pPr>
+              <a:spcAft>
+                <a:spcPts val="1200"/>
+              </a:spcAft>
+            </a:pPr>
+            <a:r>
+              <a:rPr sz="2000" b="1">
+                <a:solidFill>
+                  <a:srgbClr val="1A1D27"/>
+                </a:solidFill>
+                <a:latin typeface="Calibri"/>
+              </a:rPr>
+              <a:t>▸  Get the token count wrong here, and every budget calculated from it downstream is wrong too</a:t>
+            </a:r>
+          </a:p>
+        </p:txBody>
+      </p:sp>
+      <p:sp>
+        <p:nvSpPr>
+          <p:cNvPr id="6" name="TextBox 5"/>
+          <p:cNvSpPr txBox="1"/>
+          <p:nvPr/>
+        </p:nvSpPr>
+        <p:spPr>
+          <a:xfrm>
+            <a:off x="11521440" y="6446520"/>
+            <a:ext cx="548640" cy="320040"/>
+          </a:xfrm>
+          <a:prstGeom prst="rect">
+            <a:avLst/>
+          </a:prstGeom>
+          <a:noFill/>
+        </p:spPr>
+        <p:txBody>
+          <a:bodyPr wrap="square">
+            <a:spAutoFit/>
+          </a:bodyPr>
+          <a:lstStyle/>
+          <a:p>
+            <a:pPr algn="r"/>
+            <a:r>
+              <a:rPr sz="1100" b="0" i="0">
+                <a:solidFill>
+                  <a:srgbClr val="5B6374"/>
+                </a:solidFill>
+                <a:latin typeface="Calibri"/>
+              </a:rPr>
+              <a:t>7</a:t>
+            </a:r>
+          </a:p>
+        </p:txBody>
+      </p:sp>
+    </p:spTree>
+  </p:cSld>
+  <p:clrMapOvr>
+    <a:masterClrMapping/>
+  </p:clrMapOvr>
+</p:sld>
+</file>
+
+<file path=ppt/slides/slide8.xml><?xml version="1.0" encoding="utf-8"?>
+<p:sld xmlns:a="http://schemas.openxmlformats.org/drawingml/2006/main" xmlns:p="http://schemas.openxmlformats.org/presentationml/2006/main" xmlns:r="http://schemas.openxmlformats.org/officeDocument/2006/relationships">
+  <p:cSld>
+    <p:bg>
+      <p:bgPr>
+        <a:solidFill>
+          <a:srgbClr val="FFFFFF"/>
+        </a:solidFill>
+        <a:effectLst/>
+      </p:bgPr>
+    </p:bg>
+    <p:spTree>
+      <p:nvGrpSpPr>
+        <p:cNvPr id="1" name=""/>
+        <p:cNvGrpSpPr/>
+        <p:nvPr/>
+      </p:nvGrpSpPr>
+      <p:grpSpPr/>
+      <p:sp>
+        <p:nvSpPr>
+          <p:cNvPr id="2" name="Rectangle 1"/>
+          <p:cNvSpPr/>
+          <p:nvPr/>
+        </p:nvSpPr>
+        <p:spPr>
+          <a:xfrm>
+            <a:off x="0" y="0"/>
+            <a:ext cx="12191695" cy="109728"/>
+          </a:xfrm>
+          <a:prstGeom prst="rect">
+            <a:avLst/>
+          </a:prstGeom>
+          <a:solidFill>
+            <a:srgbClr val="3E8EDE"/>
+          </a:solidFill>
+          <a:ln>
+            <a:noFill/>
+          </a:ln>
+        </p:spPr>
+        <p:style>
+          <a:lnRef idx="1">
+            <a:schemeClr val="accent1"/>
+          </a:lnRef>
+          <a:fillRef idx="3">
+            <a:schemeClr val="accent1"/>
+          </a:fillRef>
+          <a:effectRef idx="2">
+            <a:schemeClr val="accent1"/>
+          </a:effectRef>
+          <a:fontRef idx="minor">
+            <a:schemeClr val="lt1"/>
+          </a:fontRef>
+        </p:style>
+        <p:txBody>
+          <a:bodyPr rtlCol="0" anchor="ctr"/>
+          <a:lstStyle/>
+          <a:p>
+            <a:pPr algn="ctr"/>
+          </a:p>
+        </p:txBody>
+      </p:sp>
+      <p:sp>
+        <p:nvSpPr>
+          <p:cNvPr id="3" name="TextBox 2"/>
+          <p:cNvSpPr txBox="1"/>
+          <p:nvPr/>
+        </p:nvSpPr>
+        <p:spPr>
+          <a:xfrm>
+            <a:off x="640080" y="411480"/>
+            <a:ext cx="10881360" cy="457200"/>
+          </a:xfrm>
+          <a:prstGeom prst="rect">
+            <a:avLst/>
+          </a:prstGeom>
+          <a:noFill/>
+        </p:spPr>
+        <p:txBody>
+          <a:bodyPr wrap="square">
+            <a:spAutoFit/>
+          </a:bodyPr>
+          <a:lstStyle/>
+          <a:p>
+            <a:pPr algn="l"/>
+            <a:r>
+              <a:rPr sz="1500" b="1" i="0">
+                <a:solidFill>
+                  <a:srgbClr val="3E8EDE"/>
+                </a:solidFill>
+                <a:latin typeface="Calibri"/>
+              </a:rPr>
+              <a:t>HOW IT'S COUNTED</a:t>
+            </a:r>
+          </a:p>
+        </p:txBody>
+      </p:sp>
+      <p:sp>
+        <p:nvSpPr>
+          <p:cNvPr id="4" name="TextBox 3"/>
+          <p:cNvSpPr txBox="1"/>
+          <p:nvPr/>
+        </p:nvSpPr>
+        <p:spPr>
+          <a:xfrm>
+            <a:off x="640080" y="777240"/>
+            <a:ext cx="10881360" cy="822960"/>
+          </a:xfrm>
+          <a:prstGeom prst="rect">
+            <a:avLst/>
+          </a:prstGeom>
+          <a:noFill/>
+        </p:spPr>
+        <p:txBody>
+          <a:bodyPr wrap="square">
+            <a:spAutoFit/>
+          </a:bodyPr>
+          <a:lstStyle/>
+          <a:p>
+            <a:pPr algn="l"/>
+            <a:r>
+              <a:rPr sz="3000" b="1" i="0">
+                <a:solidFill>
+                  <a:srgbClr val="1A1D27"/>
+                </a:solidFill>
+                <a:latin typeface="Calibri"/>
+              </a:rPr>
+              <a:t>The Same Tokenizer the Extraction Model Used</a:t>
+            </a:r>
+          </a:p>
+        </p:txBody>
+      </p:sp>
+      <p:sp>
+        <p:nvSpPr>
+          <p:cNvPr id="5" name="TextBox 4"/>
+          <p:cNvSpPr txBox="1"/>
+          <p:nvPr/>
+        </p:nvSpPr>
+        <p:spPr>
+          <a:xfrm>
+            <a:off x="731520" y="1691640"/>
+            <a:ext cx="10698480" cy="4480560"/>
+          </a:xfrm>
+          <a:prstGeom prst="rect">
+            <a:avLst/>
+          </a:prstGeom>
+          <a:noFill/>
+        </p:spPr>
+        <p:txBody>
+          <a:bodyPr wrap="square">
+            <a:spAutoFit/>
+          </a:bodyPr>
+          <a:lstStyle/>
+          <a:p>
+            <a:pPr>
+              <a:spcAft>
+                <a:spcPts val="1200"/>
+              </a:spcAft>
+            </a:pPr>
+            <a:r>
+              <a:rPr sz="2000" b="1">
+                <a:solidFill>
+                  <a:srgbClr val="1A1D27"/>
+                </a:solidFill>
+                <a:latin typeface="Calibri"/>
+              </a:rPr>
+              <a:t>▸  This module counts tokens with the exact tokenizer Qwen3.5-0.8B (Module 1's extraction model) uses</a:t>
+            </a:r>
+          </a:p>
+          <a:p>
+            <a:pPr>
+              <a:spcAft>
+                <a:spcPts val="1200"/>
+              </a:spcAft>
+            </a:pPr>
+            <a:r>
+              <a:rPr sz="2000" b="1">
+                <a:solidFill>
+                  <a:srgbClr val="1A1D27"/>
+                </a:solidFill>
+                <a:latin typeface="Calibri"/>
+              </a:rPr>
+              <a:t>▸  Not an estimate, not a generic word-to-token multiplier -- the real tokenizer, run for real, on every document</a:t>
+            </a:r>
+          </a:p>
+          <a:p>
+            <a:pPr>
+              <a:spcAft>
+                <a:spcPts val="1200"/>
+              </a:spcAft>
+            </a:pPr>
+            <a:r>
+              <a:rPr sz="2000" b="1">
+                <a:solidFill>
+                  <a:srgbClr val="1A1D27"/>
+                </a:solidFill>
+                <a:latin typeface="Calibri"/>
+              </a:rPr>
+              <a:t>▸  An approximation here wouldn't just be slightly off -- it would quietly mislead every token-budgeted step that reads this number afterward</a:t>
+            </a:r>
+          </a:p>
+        </p:txBody>
+      </p:sp>
+      <p:sp>
+        <p:nvSpPr>
+          <p:cNvPr id="6" name="TextBox 5"/>
+          <p:cNvSpPr txBox="1"/>
+          <p:nvPr/>
+        </p:nvSpPr>
+        <p:spPr>
+          <a:xfrm>
+            <a:off x="11521440" y="6446520"/>
+            <a:ext cx="548640" cy="320040"/>
+          </a:xfrm>
+          <a:prstGeom prst="rect">
+            <a:avLst/>
+          </a:prstGeom>
+          <a:noFill/>
+        </p:spPr>
+        <p:txBody>
+          <a:bodyPr wrap="square">
+            <a:spAutoFit/>
+          </a:bodyPr>
+          <a:lstStyle/>
+          <a:p>
+            <a:pPr algn="r"/>
+            <a:r>
+              <a:rPr sz="1100" b="0" i="0">
+                <a:solidFill>
+                  <a:srgbClr val="5B6374"/>
+                </a:solidFill>
+                <a:latin typeface="Calibri"/>
+              </a:rPr>
+              <a:t>8</a:t>
+            </a:r>
+          </a:p>
+        </p:txBody>
+      </p:sp>
+    </p:spTree>
+  </p:cSld>
+  <p:clrMapOvr>
+    <a:masterClrMapping/>
+  </p:clrMapOvr>
+</p:sld>
+</file>
+
+<file path=ppt/slides/slide9.xml><?xml version="1.0" encoding="utf-8"?>
 <p:sld xmlns:a="http://schemas.openxmlformats.org/drawingml/2006/main" xmlns:p="http://schemas.openxmlformats.org/presentationml/2006/main" xmlns:r="http://schemas.openxmlformats.org/officeDocument/2006/relationships">
   <p:cSld>
     <p:bg>
@@ -7119,576 +8871,6 @@
                 </a:solidFill>
                 <a:latin typeface="Calibri"/>
               </a:rPr>
-              <a:t>7</a:t>
-            </a:r>
-          </a:p>
-        </p:txBody>
-      </p:sp>
-    </p:spTree>
-  </p:cSld>
-  <p:clrMapOvr>
-    <a:masterClrMapping/>
-  </p:clrMapOvr>
-</p:sld>
-</file>
-
-<file path=ppt/slides/slide8.xml><?xml version="1.0" encoding="utf-8"?>
-<p:sld xmlns:a="http://schemas.openxmlformats.org/drawingml/2006/main" xmlns:p="http://schemas.openxmlformats.org/presentationml/2006/main" xmlns:r="http://schemas.openxmlformats.org/officeDocument/2006/relationships">
-  <p:cSld>
-    <p:bg>
-      <p:bgPr>
-        <a:solidFill>
-          <a:srgbClr val="FFFFFF"/>
-        </a:solidFill>
-        <a:effectLst/>
-      </p:bgPr>
-    </p:bg>
-    <p:spTree>
-      <p:nvGrpSpPr>
-        <p:cNvPr id="1" name=""/>
-        <p:cNvGrpSpPr/>
-        <p:nvPr/>
-      </p:nvGrpSpPr>
-      <p:grpSpPr/>
-      <p:sp>
-        <p:nvSpPr>
-          <p:cNvPr id="2" name="Rectangle 1"/>
-          <p:cNvSpPr/>
-          <p:nvPr/>
-        </p:nvSpPr>
-        <p:spPr>
-          <a:xfrm>
-            <a:off x="0" y="0"/>
-            <a:ext cx="12191695" cy="109728"/>
-          </a:xfrm>
-          <a:prstGeom prst="rect">
-            <a:avLst/>
-          </a:prstGeom>
-          <a:solidFill>
-            <a:srgbClr val="3E8EDE"/>
-          </a:solidFill>
-          <a:ln>
-            <a:noFill/>
-          </a:ln>
-        </p:spPr>
-        <p:style>
-          <a:lnRef idx="1">
-            <a:schemeClr val="accent1"/>
-          </a:lnRef>
-          <a:fillRef idx="3">
-            <a:schemeClr val="accent1"/>
-          </a:fillRef>
-          <a:effectRef idx="2">
-            <a:schemeClr val="accent1"/>
-          </a:effectRef>
-          <a:fontRef idx="minor">
-            <a:schemeClr val="lt1"/>
-          </a:fontRef>
-        </p:style>
-        <p:txBody>
-          <a:bodyPr rtlCol="0" anchor="ctr"/>
-          <a:lstStyle/>
-          <a:p>
-            <a:pPr algn="ctr"/>
-          </a:p>
-        </p:txBody>
-      </p:sp>
-      <p:sp>
-        <p:nvSpPr>
-          <p:cNvPr id="3" name="TextBox 2"/>
-          <p:cNvSpPr txBox="1"/>
-          <p:nvPr/>
-        </p:nvSpPr>
-        <p:spPr>
-          <a:xfrm>
-            <a:off x="640080" y="411480"/>
-            <a:ext cx="10881360" cy="457200"/>
-          </a:xfrm>
-          <a:prstGeom prst="rect">
-            <a:avLst/>
-          </a:prstGeom>
-          <a:noFill/>
-        </p:spPr>
-        <p:txBody>
-          <a:bodyPr wrap="square">
-            <a:spAutoFit/>
-          </a:bodyPr>
-          <a:lstStyle/>
-          <a:p>
-            <a:pPr algn="l"/>
-            <a:r>
-              <a:rPr sz="1500" b="1" i="0">
-                <a:solidFill>
-                  <a:srgbClr val="3E8EDE"/>
-                </a:solidFill>
-                <a:latin typeface="Calibri"/>
-              </a:rPr>
-              <a:t>LAYOUT ANALYSIS</a:t>
-            </a:r>
-          </a:p>
-        </p:txBody>
-      </p:sp>
-      <p:sp>
-        <p:nvSpPr>
-          <p:cNvPr id="4" name="TextBox 3"/>
-          <p:cNvSpPr txBox="1"/>
-          <p:nvPr/>
-        </p:nvSpPr>
-        <p:spPr>
-          <a:xfrm>
-            <a:off x="640080" y="777240"/>
-            <a:ext cx="10881360" cy="822960"/>
-          </a:xfrm>
-          <a:prstGeom prst="rect">
-            <a:avLst/>
-          </a:prstGeom>
-          <a:noFill/>
-        </p:spPr>
-        <p:txBody>
-          <a:bodyPr wrap="square">
-            <a:spAutoFit/>
-          </a:bodyPr>
-          <a:lstStyle/>
-          <a:p>
-            <a:pPr algn="l"/>
-            <a:r>
-              <a:rPr sz="3000" b="1" i="0">
-                <a:solidFill>
-                  <a:srgbClr val="1A1D27"/>
-                </a:solidFill>
-                <a:latin typeface="Calibri"/>
-              </a:rPr>
-              <a:t>The Other Half of Validation</a:t>
-            </a:r>
-          </a:p>
-        </p:txBody>
-      </p:sp>
-      <p:sp>
-        <p:nvSpPr>
-          <p:cNvPr id="5" name="TextBox 4"/>
-          <p:cNvSpPr txBox="1"/>
-          <p:nvPr/>
-        </p:nvSpPr>
-        <p:spPr>
-          <a:xfrm>
-            <a:off x="731520" y="1691640"/>
-            <a:ext cx="10698480" cy="4480560"/>
-          </a:xfrm>
-          <a:prstGeom prst="rect">
-            <a:avLst/>
-          </a:prstGeom>
-          <a:noFill/>
-        </p:spPr>
-        <p:txBody>
-          <a:bodyPr wrap="square">
-            <a:spAutoFit/>
-          </a:bodyPr>
-          <a:lstStyle/>
-          <a:p>
-            <a:pPr>
-              <a:spcAft>
-                <a:spcPts val="1000"/>
-              </a:spcAft>
-            </a:pPr>
-            <a:r>
-              <a:rPr sz="1800" b="1">
-                <a:solidFill>
-                  <a:srgbClr val="1A1D27"/>
-                </a:solidFill>
-                <a:latin typeface="Calibri"/>
-              </a:rPr>
-              <a:t>▸  Token counting tells you how much content came out. It says nothing about whether the layout detector actually understood the page</a:t>
-            </a:r>
-          </a:p>
-          <a:p>
-            <a:pPr>
-              <a:spcAft>
-                <a:spcPts val="1000"/>
-              </a:spcAft>
-            </a:pPr>
-            <a:r>
-              <a:rPr sz="1800" b="1">
-                <a:solidFill>
-                  <a:srgbClr val="1A1D27"/>
-                </a:solidFill>
-                <a:latin typeface="Calibri"/>
-              </a:rPr>
-              <a:t>▸  Module 1's layout detector already assigns a confidence score to every region it finds -- Module 2 doesn't compute this, it surfaces what already exists</a:t>
-            </a:r>
-          </a:p>
-          <a:p>
-            <a:pPr>
-              <a:spcAft>
-                <a:spcPts val="500"/>
-              </a:spcAft>
-            </a:pPr>
-            <a:r>
-              <a:rPr sz="1500" b="0">
-                <a:solidFill>
-                  <a:srgbClr val="5B6374"/>
-                </a:solidFill>
-                <a:latin typeface="Calibri"/>
-              </a:rPr>
-              <a:t>     –  low_confidence_regions -- the detector found something there, but wasn't sure what</a:t>
-            </a:r>
-          </a:p>
-          <a:p>
-            <a:pPr>
-              <a:spcAft>
-                <a:spcPts val="500"/>
-              </a:spcAft>
-            </a:pPr>
-            <a:r>
-              <a:rPr sz="1500" b="0">
-                <a:solidFill>
-                  <a:srgbClr val="5B6374"/>
-                </a:solidFill>
-                <a:latin typeface="Calibri"/>
-              </a:rPr>
-              <a:t>     –  dropped_regions -- the detector excluded a region entirely: correctly (headers/footers), or not (see the case study ahead)</a:t>
-            </a:r>
-          </a:p>
-          <a:p>
-            <a:pPr>
-              <a:spcAft>
-                <a:spcPts val="1000"/>
-              </a:spcAft>
-            </a:pPr>
-            <a:r>
-              <a:rPr sz="1800" b="1">
-                <a:solidFill>
-                  <a:srgbClr val="1A1D27"/>
-                </a:solidFill>
-                <a:latin typeface="Calibri"/>
-              </a:rPr>
-              <a:t>▸  Same source also covers artifacts (logos, signatures, stamp/seals) and malformed tables -- structural failures, not content-volume ones</a:t>
-            </a:r>
-          </a:p>
-          <a:p>
-            <a:pPr>
-              <a:spcAft>
-                <a:spcPts val="1000"/>
-              </a:spcAft>
-            </a:pPr>
-            <a:r>
-              <a:rPr sz="1800" b="1">
-                <a:solidFill>
-                  <a:srgbClr val="1A1D27"/>
-                </a:solidFill>
-                <a:latin typeface="Calibri"/>
-              </a:rPr>
-              <a:t>▸  Two independent questions: token analysis asks “how much came out,” layout analysis asks “did it even see the page correctly”</a:t>
-            </a:r>
-          </a:p>
-        </p:txBody>
-      </p:sp>
-      <p:sp>
-        <p:nvSpPr>
-          <p:cNvPr id="6" name="TextBox 5"/>
-          <p:cNvSpPr txBox="1"/>
-          <p:nvPr/>
-        </p:nvSpPr>
-        <p:spPr>
-          <a:xfrm>
-            <a:off x="11521440" y="6446520"/>
-            <a:ext cx="548640" cy="320040"/>
-          </a:xfrm>
-          <a:prstGeom prst="rect">
-            <a:avLst/>
-          </a:prstGeom>
-          <a:noFill/>
-        </p:spPr>
-        <p:txBody>
-          <a:bodyPr wrap="square">
-            <a:spAutoFit/>
-          </a:bodyPr>
-          <a:lstStyle/>
-          <a:p>
-            <a:pPr algn="r"/>
-            <a:r>
-              <a:rPr sz="1100" b="0" i="0">
-                <a:solidFill>
-                  <a:srgbClr val="5B6374"/>
-                </a:solidFill>
-                <a:latin typeface="Calibri"/>
-              </a:rPr>
-              <a:t>8</a:t>
-            </a:r>
-          </a:p>
-        </p:txBody>
-      </p:sp>
-    </p:spTree>
-  </p:cSld>
-  <p:clrMapOvr>
-    <a:masterClrMapping/>
-  </p:clrMapOvr>
-</p:sld>
-</file>
-
-<file path=ppt/slides/slide9.xml><?xml version="1.0" encoding="utf-8"?>
-<p:sld xmlns:a="http://schemas.openxmlformats.org/drawingml/2006/main" xmlns:p="http://schemas.openxmlformats.org/presentationml/2006/main" xmlns:r="http://schemas.openxmlformats.org/officeDocument/2006/relationships">
-  <p:cSld>
-    <p:bg>
-      <p:bgPr>
-        <a:solidFill>
-          <a:srgbClr val="FFFFFF"/>
-        </a:solidFill>
-        <a:effectLst/>
-      </p:bgPr>
-    </p:bg>
-    <p:spTree>
-      <p:nvGrpSpPr>
-        <p:cNvPr id="1" name=""/>
-        <p:cNvGrpSpPr/>
-        <p:nvPr/>
-      </p:nvGrpSpPr>
-      <p:grpSpPr/>
-      <p:sp>
-        <p:nvSpPr>
-          <p:cNvPr id="2" name="Rectangle 1"/>
-          <p:cNvSpPr/>
-          <p:nvPr/>
-        </p:nvSpPr>
-        <p:spPr>
-          <a:xfrm>
-            <a:off x="0" y="0"/>
-            <a:ext cx="12191695" cy="109728"/>
-          </a:xfrm>
-          <a:prstGeom prst="rect">
-            <a:avLst/>
-          </a:prstGeom>
-          <a:solidFill>
-            <a:srgbClr val="3E8EDE"/>
-          </a:solidFill>
-          <a:ln>
-            <a:noFill/>
-          </a:ln>
-        </p:spPr>
-        <p:style>
-          <a:lnRef idx="1">
-            <a:schemeClr val="accent1"/>
-          </a:lnRef>
-          <a:fillRef idx="3">
-            <a:schemeClr val="accent1"/>
-          </a:fillRef>
-          <a:effectRef idx="2">
-            <a:schemeClr val="accent1"/>
-          </a:effectRef>
-          <a:fontRef idx="minor">
-            <a:schemeClr val="lt1"/>
-          </a:fontRef>
-        </p:style>
-        <p:txBody>
-          <a:bodyPr rtlCol="0" anchor="ctr"/>
-          <a:lstStyle/>
-          <a:p>
-            <a:pPr algn="ctr"/>
-          </a:p>
-        </p:txBody>
-      </p:sp>
-      <p:sp>
-        <p:nvSpPr>
-          <p:cNvPr id="3" name="TextBox 2"/>
-          <p:cNvSpPr txBox="1"/>
-          <p:nvPr/>
-        </p:nvSpPr>
-        <p:spPr>
-          <a:xfrm>
-            <a:off x="640080" y="411480"/>
-            <a:ext cx="10881360" cy="457200"/>
-          </a:xfrm>
-          <a:prstGeom prst="rect">
-            <a:avLst/>
-          </a:prstGeom>
-          <a:noFill/>
-        </p:spPr>
-        <p:txBody>
-          <a:bodyPr wrap="square">
-            <a:spAutoFit/>
-          </a:bodyPr>
-          <a:lstStyle/>
-          <a:p>
-            <a:pPr algn="l"/>
-            <a:r>
-              <a:rPr sz="1500" b="1" i="0">
-                <a:solidFill>
-                  <a:srgbClr val="3E8EDE"/>
-                </a:solidFill>
-                <a:latin typeface="Calibri"/>
-              </a:rPr>
-              <a:t>THE DELIVERABLE</a:t>
-            </a:r>
-          </a:p>
-        </p:txBody>
-      </p:sp>
-      <p:sp>
-        <p:nvSpPr>
-          <p:cNvPr id="4" name="TextBox 3"/>
-          <p:cNvSpPr txBox="1"/>
-          <p:nvPr/>
-        </p:nvSpPr>
-        <p:spPr>
-          <a:xfrm>
-            <a:off x="640080" y="777240"/>
-            <a:ext cx="10881360" cy="822960"/>
-          </a:xfrm>
-          <a:prstGeom prst="rect">
-            <a:avLst/>
-          </a:prstGeom>
-          <a:noFill/>
-        </p:spPr>
-        <p:txBody>
-          <a:bodyPr wrap="square">
-            <a:spAutoFit/>
-          </a:bodyPr>
-          <a:lstStyle/>
-          <a:p>
-            <a:pPr algn="l"/>
-            <a:r>
-              <a:rPr sz="3000" b="1" i="0">
-                <a:solidFill>
-                  <a:srgbClr val="1A1D27"/>
-                </a:solidFill>
-                <a:latin typeface="Calibri"/>
-              </a:rPr>
-              <a:t>One Workbook, Built for Validation</a:t>
-            </a:r>
-          </a:p>
-        </p:txBody>
-      </p:sp>
-      <p:sp>
-        <p:nvSpPr>
-          <p:cNvPr id="5" name="TextBox 4"/>
-          <p:cNvSpPr txBox="1"/>
-          <p:nvPr/>
-        </p:nvSpPr>
-        <p:spPr>
-          <a:xfrm>
-            <a:off x="731520" y="1691640"/>
-            <a:ext cx="10698480" cy="4480560"/>
-          </a:xfrm>
-          <a:prstGeom prst="rect">
-            <a:avLst/>
-          </a:prstGeom>
-          <a:noFill/>
-        </p:spPr>
-        <p:txBody>
-          <a:bodyPr wrap="square">
-            <a:spAutoFit/>
-          </a:bodyPr>
-          <a:lstStyle/>
-          <a:p>
-            <a:pPr>
-              <a:spcAft>
-                <a:spcPts val="1200"/>
-              </a:spcAft>
-            </a:pPr>
-            <a:r>
-              <a:rPr sz="2000" b="1">
-                <a:solidFill>
-                  <a:srgbClr val="1A1D27"/>
-                </a:solidFill>
-                <a:latin typeface="Calibri"/>
-              </a:rPr>
-              <a:t>▸  Summary -- one row per document, every stat from the last two slides in one place, built to be scanned fast</a:t>
-            </a:r>
-          </a:p>
-          <a:p>
-            <a:pPr>
-              <a:spcAft>
-                <a:spcPts val="1200"/>
-              </a:spcAft>
-            </a:pPr>
-            <a:r>
-              <a:rPr sz="2000" b="1">
-                <a:solidFill>
-                  <a:srgbClr val="1A1D27"/>
-                </a:solidFill>
-                <a:latin typeface="Calibri"/>
-              </a:rPr>
-              <a:t>▸  Artifacts Detail -- one row per detected logo/signature/stamp: page, description, exact location</a:t>
-            </a:r>
-          </a:p>
-          <a:p>
-            <a:pPr>
-              <a:spcAft>
-                <a:spcPts val="1200"/>
-              </a:spcAft>
-            </a:pPr>
-            <a:r>
-              <a:rPr sz="2000" b="1">
-                <a:solidFill>
-                  <a:srgbClr val="1A1D27"/>
-                </a:solidFill>
-                <a:latin typeface="Calibri"/>
-              </a:rPr>
-              <a:t>▸  Low Confidence Regions -- one row per region the layout detector wasn't sure about</a:t>
-            </a:r>
-          </a:p>
-          <a:p>
-            <a:pPr>
-              <a:spcAft>
-                <a:spcPts val="1200"/>
-              </a:spcAft>
-            </a:pPr>
-            <a:r>
-              <a:rPr sz="2000" b="1">
-                <a:solidFill>
-                  <a:srgbClr val="1A1D27"/>
-                </a:solidFill>
-                <a:latin typeface="Calibri"/>
-              </a:rPr>
-              <a:t>▸  Dropped Regions -- one row per region excluded from the document, including anything misclassified and dropped by mistake</a:t>
-            </a:r>
-          </a:p>
-          <a:p>
-            <a:pPr>
-              <a:spcAft>
-                <a:spcPts val="600"/>
-              </a:spcAft>
-            </a:pPr>
-            <a:r>
-              <a:rPr sz="1600" b="0">
-                <a:solidFill>
-                  <a:srgbClr val="5B6374"/>
-                </a:solidFill>
-                <a:latin typeface="Calibri"/>
-              </a:rPr>
-              <a:t>     –  Every flagged row carries a location back to the original page -- a finding is only useful if it can be checked</a:t>
-            </a:r>
-          </a:p>
-        </p:txBody>
-      </p:sp>
-      <p:sp>
-        <p:nvSpPr>
-          <p:cNvPr id="6" name="TextBox 5"/>
-          <p:cNvSpPr txBox="1"/>
-          <p:nvPr/>
-        </p:nvSpPr>
-        <p:spPr>
-          <a:xfrm>
-            <a:off x="11521440" y="6446520"/>
-            <a:ext cx="548640" cy="320040"/>
-          </a:xfrm>
-          <a:prstGeom prst="rect">
-            <a:avLst/>
-          </a:prstGeom>
-          <a:noFill/>
-        </p:spPr>
-        <p:txBody>
-          <a:bodyPr wrap="square">
-            <a:spAutoFit/>
-          </a:bodyPr>
-          <a:lstStyle/>
-          <a:p>
-            <a:pPr algn="r"/>
-            <a:r>
-              <a:rPr sz="1100" b="0" i="0">
-                <a:solidFill>
-                  <a:srgbClr val="5B6374"/>
-                </a:solidFill>
-                <a:latin typeface="Calibri"/>
-              </a:rPr>
               <a:t>9</a:t>
             </a:r>
           </a:p>

</xml_diff>